<commit_message>
Replace W3L1 You Do activity with a healthy-food reverse-engineering task
Students are now shown the finished webpage text (title, intro
paragraph, three subheadings with short paragraphs) and write the
HTML needed to reproduce it, instead of sketching a hierarchy on
paper. Old deck and worksheet backed up under resources/week-03/backups/.

Co-Authored-By: Claude Sonnet 5 <noreply@anthropic.com>
</commit_message>
<xml_diff>
--- a/resources/week-03/W3L1 - Headings & Paragraphs - Structuring Text.pptx
+++ b/resources/week-03/W3L1 - Headings & Paragraphs - Structuring Text.pptx
@@ -5901,7 +5901,7 @@
                 <a:ea typeface="Arial" pitchFamily="34" charset="-122"/>
                 <a:cs typeface="Arial" pitchFamily="34" charset="-120"/>
               </a:rPr>
-              <a:t>You Do: Plan Your Hierarchy</a:t>
+              <a:t>You Do: Code the Healthy Food Page</a:t>
             </a:r>
             <a:endParaRPr lang="en-US" sz="1500" dirty="0"/>
           </a:p>
@@ -5924,7 +5924,7 @@
                 <a:ea typeface="Arial" pitchFamily="34" charset="-122"/>
                 <a:cs typeface="Arial" pitchFamily="34" charset="-120"/>
               </a:rPr>
-              <a:t>On paper, sketch the heading hierarchy (h1/h2/h3) for your own homepage - before touching any code.</a:t>
+              <a:t>You're given the finished webpage - write the HTML code that would build it, using the right heading and paragraph tags.</a:t>
             </a:r>
             <a:endParaRPr lang="en-US" sz="1500" dirty="0"/>
           </a:p>
@@ -5963,7 +5963,7 @@
                 <a:ea typeface="Arial" pitchFamily="34" charset="-122"/>
                 <a:cs typeface="Arial" pitchFamily="34" charset="-120"/>
               </a:rPr>
-              <a:t>Activity: Planning Your Heading Hierarchy</a:t>
+              <a:t>Activity: Code This Page - Healthy Food</a:t>
             </a:r>
             <a:endParaRPr lang="en-US" sz="1050" dirty="0"/>
           </a:p>
@@ -5996,7 +5996,7 @@
       </p:sp>
       <p:pic>
         <p:nvPicPr>
-          <p:cNvPr id="14" name="Image 2" descr="C:\Users\a.abboud\Desktop\html unit\resources\week-03\scratch\assets\W3L1 - Planning Your Heading Hierarchy_cropped.png">    </p:cNvPr>
+          <p:cNvPr id="14" name="Image 2" descr="C:\Users\a.abboud\Desktop\html unit\resources\week-03\scratch\assets\W3L1 - Code This Page - Healthy Food_cropped.png">    </p:cNvPr>
           <p:cNvPicPr>
             <a:picLocks noChangeAspect="1"/>
           </p:cNvPicPr>
@@ -6010,8 +6010,8 @@
         </p:blipFill>
         <p:spPr>
           <a:xfrm>
-            <a:off x="6582641" y="1792224"/>
-            <a:ext cx="1712006" cy="2368296"/>
+            <a:off x="6546822" y="1792224"/>
+            <a:ext cx="1783643" cy="2368296"/>
           </a:xfrm>
           <a:prstGeom prst="rect">
             <a:avLst/>

</xml_diff>

<commit_message>
Show the rendered example on W3L1's We Do slide; add Extension/Support for the healthy food activity
The We Do: 3 Reads slide referenced "the example" without showing it -
now includes a small rendered preview of the I Do demo page (My
Website / About Me / My Hobbies) so students can actually read it.

Also adds Extension and Support versions of the Code This Page:
Healthy Food activity, matching the differentiation pattern used
elsewhere in Week 3 (challenge extension section; hint bank + worked
example scaffolding).

Co-Authored-By: Claude Sonnet 5 <noreply@anthropic.com>
</commit_message>
<xml_diff>
--- a/resources/week-03/W3L1 - Headings & Paragraphs - Structuring Text.pptx
+++ b/resources/week-03/W3L1 - Headings & Paragraphs - Structuring Text.pptx
@@ -4,6 +4,9 @@
   <p:sldMasterIdLst>
     <p:sldMasterId id="2147483648" r:id="rId1"/>
   </p:sldMasterIdLst>
+  <p:notesMasterIdLst>
+    <p:notesMasterId r:id="rId13"/>
+  </p:notesMasterIdLst>
   <p:sldIdLst>
     <p:sldId id="256" r:id="rId2"/>
     <p:sldId id="257" r:id="rId3"/>
@@ -13,13 +16,11 @@
     <p:sldId id="261" r:id="rId7"/>
     <p:sldId id="262" r:id="rId8"/>
     <p:sldId id="263" r:id="rId9"/>
-    <p:sldId id="264" r:id="rId10"/>
-    <p:sldId id="265" r:id="rId11"/>
+    <p:sldId id="266" r:id="rId10"/>
+    <p:sldId id="264" r:id="rId11"/>
+    <p:sldId id="265" r:id="rId12"/>
   </p:sldIdLst>
-  <p:notesMasterIdLst>
-    <p:notesMasterId r:id="rId12"/>
-  </p:notesMasterIdLst>
-  <p:sldSz cx="9144000" cy="5143500"/>
+  <p:sldSz cx="9144000" cy="5143500" type="screen16x9"/>
   <p:notesSz cx="5143500" cy="9144000"/>
   <p:defaultTextStyle>
     <a:lvl1pPr marL="0" algn="l" defTabSz="914400" rtl="0" eaLnBrk="1" latinLnBrk="0" hangingPunct="1">
@@ -113,6 +114,11 @@
       </a:defRPr>
     </a:lvl9pPr>
   </p:defaultTextStyle>
+  <p:extLst>
+    <p:ext uri="{EFAFB233-063F-42B5-8137-9DF3F51BA10A}">
+      <p15:sldGuideLst xmlns:p15="http://schemas.microsoft.com/office/powerpoint/2012/main"/>
+    </p:ext>
+  </p:extLst>
 </p:presentation>
 </file>
 
@@ -138,234 +144,10 @@
           <a:chExt cx="0" cy="0"/>
         </a:xfrm>
       </p:grpSpPr>
-      <p:sp>
-        <p:nvSpPr>
-          <p:cNvPr id="2" name="Header Placeholder 1"/>
-          <p:cNvSpPr>
-            <a:spLocks noGrp="1"/>
-          </p:cNvSpPr>
-          <p:nvPr>
-            <p:ph type="hdr" sz="quarter"/>
-          </p:nvPr>
-        </p:nvSpPr>
-        <p:spPr>
-          <a:xfrm>
-            <a:off x="0" y="0"/>
-            <a:ext cx="2971800" cy="458788"/>
-          </a:xfrm>
-          <a:prstGeom prst="rect">
-            <a:avLst/>
-          </a:prstGeom>
-        </p:spPr>
-        <p:txBody>
-          <a:bodyPr vert="horz" lIns="91440" tIns="45720" rIns="91440" bIns="45720" rtlCol="0"/>
-          <a:lstStyle>
-            <a:lvl1pPr algn="l">
-              <a:defRPr sz="1200"/>
-            </a:lvl1pPr>
-          </a:lstStyle>
-          <a:p>
-            <a:endParaRPr lang="en-US"/>
-          </a:p>
-        </p:txBody>
-      </p:sp>
-      <p:sp>
-        <p:nvSpPr>
-          <p:cNvPr id="3" name="Date Placeholder 2"/>
-          <p:cNvSpPr>
-            <a:spLocks noGrp="1"/>
-          </p:cNvSpPr>
-          <p:nvPr>
-            <p:ph type="dt" idx="1"/>
-          </p:nvPr>
-        </p:nvSpPr>
-        <p:spPr>
-          <a:xfrm>
-            <a:off x="3884613" y="0"/>
-            <a:ext cx="2971800" cy="458788"/>
-          </a:xfrm>
-          <a:prstGeom prst="rect">
-            <a:avLst/>
-          </a:prstGeom>
-        </p:spPr>
-        <p:txBody>
-          <a:bodyPr vert="horz" lIns="91440" tIns="45720" rIns="91440" bIns="45720" rtlCol="0"/>
-          <a:lstStyle>
-            <a:lvl1pPr algn="r">
-              <a:defRPr sz="1200"/>
-            </a:lvl1pPr>
-          </a:lstStyle>
-          <a:p>
-            <a:fld id="{5282F153-3F37-0F45-9E97-73ACFA13230C}" type="datetimeFigureOut">
-              <a:rPr lang="en-US"/>
-              <a:t>7/23/19</a:t>
-            </a:fld>
-            <a:endParaRPr lang="en-US"/>
-          </a:p>
-        </p:txBody>
-      </p:sp>
-      <p:sp>
-        <p:nvSpPr>
-          <p:cNvPr id="4" name="Slide Image Placeholder 3"/>
-          <p:cNvSpPr>
-            <a:spLocks noGrp="1" noRot="1" noChangeAspect="1"/>
-          </p:cNvSpPr>
-          <p:nvPr>
-            <p:ph type="sldImg" idx="2"/>
-          </p:nvPr>
-        </p:nvSpPr>
-        <p:spPr>
-          <a:xfrm>
-            <a:off x="685800" y="1143000"/>
-            <a:ext cx="5486400" cy="3086100"/>
-          </a:xfrm>
-          <a:prstGeom prst="rect">
-            <a:avLst/>
-          </a:prstGeom>
-          <a:noFill/>
-          <a:ln w="12700">
-            <a:solidFill>
-              <a:prstClr val="black"/>
-            </a:solidFill>
-          </a:ln>
-        </p:spPr>
-        <p:txBody>
-          <a:bodyPr vert="horz" lIns="91440" tIns="45720" rIns="91440" bIns="45720" rtlCol="0" anchor="ctr"/>
-          <a:lstStyle/>
-          <a:p>
-            <a:endParaRPr lang="en-US"/>
-          </a:p>
-        </p:txBody>
-      </p:sp>
-      <p:sp>
-        <p:nvSpPr>
-          <p:cNvPr id="5" name="Notes Placeholder 4"/>
-          <p:cNvSpPr>
-            <a:spLocks noGrp="1"/>
-          </p:cNvSpPr>
-          <p:nvPr>
-            <p:ph type="body" sz="quarter" idx="3"/>
-          </p:nvPr>
-        </p:nvSpPr>
-        <p:spPr>
-          <a:xfrm>
-            <a:off x="685800" y="4400550"/>
-            <a:ext cx="5486400" cy="3600450"/>
-          </a:xfrm>
-          <a:prstGeom prst="rect">
-            <a:avLst/>
-          </a:prstGeom>
-        </p:spPr>
-        <p:txBody>
-          <a:bodyPr vert="horz" lIns="91440" tIns="45720" rIns="91440" bIns="45720" rtlCol="0"/>
-          <a:lstStyle/>
-          <a:p>
-            <a:pPr lvl="0"/>
-            <a:r>
-              <a:rPr lang="en-US"/>
-              <a:t>Click to edit Master text styles</a:t>
-            </a:r>
-          </a:p>
-          <a:p>
-            <a:pPr lvl="1"/>
-            <a:r>
-              <a:rPr lang="en-US"/>
-              <a:t>Second level</a:t>
-            </a:r>
-          </a:p>
-          <a:p>
-            <a:pPr lvl="2"/>
-            <a:r>
-              <a:rPr lang="en-US"/>
-              <a:t>Third level</a:t>
-            </a:r>
-          </a:p>
-          <a:p>
-            <a:pPr lvl="3"/>
-            <a:r>
-              <a:rPr lang="en-US"/>
-              <a:t>Fourth level</a:t>
-            </a:r>
-          </a:p>
-          <a:p>
-            <a:pPr lvl="4"/>
-            <a:r>
-              <a:rPr lang="en-US"/>
-              <a:t>Fifth level</a:t>
-            </a:r>
-          </a:p>
-        </p:txBody>
-      </p:sp>
-      <p:sp>
-        <p:nvSpPr>
-          <p:cNvPr id="6" name="Footer Placeholder 5"/>
-          <p:cNvSpPr>
-            <a:spLocks noGrp="1"/>
-          </p:cNvSpPr>
-          <p:nvPr>
-            <p:ph type="ftr" sz="quarter" idx="4"/>
-          </p:nvPr>
-        </p:nvSpPr>
-        <p:spPr>
-          <a:xfrm>
-            <a:off x="0" y="8685213"/>
-            <a:ext cx="2971800" cy="458787"/>
-          </a:xfrm>
-          <a:prstGeom prst="rect">
-            <a:avLst/>
-          </a:prstGeom>
-        </p:spPr>
-        <p:txBody>
-          <a:bodyPr vert="horz" lIns="91440" tIns="45720" rIns="91440" bIns="45720" rtlCol="0" anchor="b"/>
-          <a:lstStyle>
-            <a:lvl1pPr algn="l">
-              <a:defRPr sz="1200"/>
-            </a:lvl1pPr>
-          </a:lstStyle>
-          <a:p>
-            <a:endParaRPr lang="en-US"/>
-          </a:p>
-        </p:txBody>
-      </p:sp>
-      <p:sp>
-        <p:nvSpPr>
-          <p:cNvPr id="7" name="Slide Number Placeholder 6"/>
-          <p:cNvSpPr>
-            <a:spLocks noGrp="1"/>
-          </p:cNvSpPr>
-          <p:nvPr>
-            <p:ph type="sldNum" sz="quarter" idx="5"/>
-          </p:nvPr>
-        </p:nvSpPr>
-        <p:spPr>
-          <a:xfrm>
-            <a:off x="3884613" y="8685213"/>
-            <a:ext cx="2971800" cy="458787"/>
-          </a:xfrm>
-          <a:prstGeom prst="rect">
-            <a:avLst/>
-          </a:prstGeom>
-        </p:spPr>
-        <p:txBody>
-          <a:bodyPr vert="horz" lIns="91440" tIns="45720" rIns="91440" bIns="45720" rtlCol="0" anchor="b"/>
-          <a:lstStyle>
-            <a:lvl1pPr algn="r">
-              <a:defRPr sz="1200"/>
-            </a:lvl1pPr>
-          </a:lstStyle>
-          <a:p>
-            <a:fld id="{CE5E9CC1-C706-0F49-92D6-E571CC5EEA8F}" type="slidenum">
-              <a:rPr lang="en-US"/>
-              <a:t>‹#›</a:t>
-            </a:fld>
-            <a:endParaRPr lang="en-US"/>
-          </a:p>
-        </p:txBody>
-      </p:sp>
     </p:spTree>
     <p:extLst>
       <p:ext uri="{BB962C8B-B14F-4D97-AF65-F5344CB8AC3E}">
-        <p14:creationId xmlns:p14="http://schemas.microsoft.com/office/powerpoint/2010/main" val="1024086991"/>
+        <p14:creationId xmlns:p14="http://schemas.microsoft.com/office/powerpoint/2010/main" val="510112396"/>
       </p:ext>
     </p:extLst>
   </p:cSld>
@@ -509,10 +291,6 @@
           <a:bodyPr/>
           <a:lstStyle/>
           <a:p>
-            <a:r>
-              <a:rPr lang="en-US" dirty="0"/>
-              <a:t/>
-            </a:r>
             <a:endParaRPr lang="en-US" dirty="0"/>
           </a:p>
         </p:txBody>
@@ -597,10 +375,6 @@
           <a:bodyPr/>
           <a:lstStyle/>
           <a:p>
-            <a:r>
-              <a:rPr lang="en-US" dirty="0"/>
-              <a:t/>
-            </a:r>
             <a:endParaRPr lang="en-US" dirty="0"/>
           </a:p>
         </p:txBody>
@@ -623,6 +397,90 @@
             <a:fld id="{F7021451-1387-4CA6-816F-3879F97B5CBC}" type="slidenum">
               <a:rPr lang="en-US"/>
               <a:t>10</a:t>
+            </a:fld>
+            <a:endParaRPr lang="en-US"/>
+          </a:p>
+        </p:txBody>
+      </p:sp>
+    </p:spTree>
+    <p:extLst>
+      <p:ext uri="{BB962C8B-B14F-4D97-AF65-F5344CB8AC3E}">
+        <p14:creationId xmlns:p14="http://schemas.microsoft.com/office/powerpoint/2010/main" val="1024086991"/>
+      </p:ext>
+    </p:extLst>
+  </p:cSld>
+  <p:clrMapOvr>
+    <a:masterClrMapping/>
+  </p:clrMapOvr>
+</p:notes>
+</file>
+
+<file path=ppt/notesSlides/notesSlide11.xml><?xml version="1.0" encoding="utf-8"?>
+<p:notes xmlns:a="http://schemas.openxmlformats.org/drawingml/2006/main" xmlns:r="http://schemas.openxmlformats.org/officeDocument/2006/relationships" xmlns:p="http://schemas.openxmlformats.org/presentationml/2006/main">
+  <p:cSld>
+    <p:spTree>
+      <p:nvGrpSpPr>
+        <p:cNvPr id="1" name=""/>
+        <p:cNvGrpSpPr/>
+        <p:nvPr/>
+      </p:nvGrpSpPr>
+      <p:grpSpPr>
+        <a:xfrm>
+          <a:off x="0" y="0"/>
+          <a:ext cx="0" cy="0"/>
+          <a:chOff x="0" y="0"/>
+          <a:chExt cx="0" cy="0"/>
+        </a:xfrm>
+      </p:grpSpPr>
+      <p:sp>
+        <p:nvSpPr>
+          <p:cNvPr id="2" name="Slide Image Placeholder 1"/>
+          <p:cNvSpPr>
+            <a:spLocks noGrp="1" noRot="1" noChangeAspect="1"/>
+          </p:cNvSpPr>
+          <p:nvPr>
+            <p:ph type="sldImg"/>
+          </p:nvPr>
+        </p:nvSpPr>
+        <p:spPr/>
+      </p:sp>
+      <p:sp>
+        <p:nvSpPr>
+          <p:cNvPr id="3" name="Notes Placeholder 2"/>
+          <p:cNvSpPr>
+            <a:spLocks noGrp="1"/>
+          </p:cNvSpPr>
+          <p:nvPr>
+            <p:ph type="body" idx="1"/>
+          </p:nvPr>
+        </p:nvSpPr>
+        <p:spPr/>
+        <p:txBody>
+          <a:bodyPr/>
+          <a:lstStyle/>
+          <a:p>
+            <a:endParaRPr lang="en-US" dirty="0"/>
+          </a:p>
+        </p:txBody>
+      </p:sp>
+      <p:sp>
+        <p:nvSpPr>
+          <p:cNvPr id="4" name="Slide Number Placeholder 3"/>
+          <p:cNvSpPr>
+            <a:spLocks noGrp="1"/>
+          </p:cNvSpPr>
+          <p:nvPr>
+            <p:ph type="sldNum" sz="quarter" idx="10"/>
+          </p:nvPr>
+        </p:nvSpPr>
+        <p:spPr/>
+        <p:txBody>
+          <a:bodyPr/>
+          <a:lstStyle/>
+          <a:p>
+            <a:fld id="{F7021451-1387-4CA6-816F-3879F97B5CBC}" type="slidenum">
+              <a:rPr lang="en-US"/>
+              <a:t>11</a:t>
             </a:fld>
             <a:endParaRPr lang="en-US"/>
           </a:p>
@@ -685,10 +543,6 @@
           <a:bodyPr/>
           <a:lstStyle/>
           <a:p>
-            <a:r>
-              <a:rPr lang="en-US" dirty="0"/>
-              <a:t/>
-            </a:r>
             <a:endParaRPr lang="en-US" dirty="0"/>
           </a:p>
         </p:txBody>
@@ -773,10 +627,6 @@
           <a:bodyPr/>
           <a:lstStyle/>
           <a:p>
-            <a:r>
-              <a:rPr lang="en-US" dirty="0"/>
-              <a:t/>
-            </a:r>
             <a:endParaRPr lang="en-US" dirty="0"/>
           </a:p>
         </p:txBody>
@@ -861,10 +711,6 @@
           <a:bodyPr/>
           <a:lstStyle/>
           <a:p>
-            <a:r>
-              <a:rPr lang="en-US" dirty="0"/>
-              <a:t/>
-            </a:r>
             <a:endParaRPr lang="en-US" dirty="0"/>
           </a:p>
         </p:txBody>
@@ -949,10 +795,6 @@
           <a:bodyPr/>
           <a:lstStyle/>
           <a:p>
-            <a:r>
-              <a:rPr lang="en-US" dirty="0"/>
-              <a:t/>
-            </a:r>
             <a:endParaRPr lang="en-US" dirty="0"/>
           </a:p>
         </p:txBody>
@@ -1037,10 +879,6 @@
           <a:bodyPr/>
           <a:lstStyle/>
           <a:p>
-            <a:r>
-              <a:rPr lang="en-US" dirty="0"/>
-              <a:t/>
-            </a:r>
             <a:endParaRPr lang="en-US" dirty="0"/>
           </a:p>
         </p:txBody>
@@ -1125,10 +963,6 @@
           <a:bodyPr/>
           <a:lstStyle/>
           <a:p>
-            <a:r>
-              <a:rPr lang="en-US" dirty="0"/>
-              <a:t/>
-            </a:r>
             <a:endParaRPr lang="en-US" dirty="0"/>
           </a:p>
         </p:txBody>
@@ -1213,10 +1047,6 @@
           <a:bodyPr/>
           <a:lstStyle/>
           <a:p>
-            <a:r>
-              <a:rPr lang="en-US" dirty="0"/>
-              <a:t/>
-            </a:r>
             <a:endParaRPr lang="en-US" dirty="0"/>
           </a:p>
         </p:txBody>
@@ -1262,7 +1092,13 @@
   <p:cSld>
     <p:spTree>
       <p:nvGrpSpPr>
-        <p:cNvPr id="1" name=""/>
+        <p:cNvPr id="1" name="">
+          <a:extLst>
+            <a:ext uri="{FF2B5EF4-FFF2-40B4-BE49-F238E27FC236}">
+              <a16:creationId xmlns:a16="http://schemas.microsoft.com/office/drawing/2014/main" id="{5A68F577-C0A7-F3E6-B742-9433B495CFB3}"/>
+            </a:ext>
+          </a:extLst>
+        </p:cNvPr>
         <p:cNvGrpSpPr/>
         <p:nvPr/>
       </p:nvGrpSpPr>
@@ -1276,7 +1112,13 @@
       </p:grpSpPr>
       <p:sp>
         <p:nvSpPr>
-          <p:cNvPr id="2" name="Slide Image Placeholder 1"/>
+          <p:cNvPr id="2" name="Slide Image Placeholder 1">
+            <a:extLst>
+              <a:ext uri="{FF2B5EF4-FFF2-40B4-BE49-F238E27FC236}">
+                <a16:creationId xmlns:a16="http://schemas.microsoft.com/office/drawing/2014/main" id="{7180898B-C34B-56EC-B71A-6B3638C9B3B6}"/>
+              </a:ext>
+            </a:extLst>
+          </p:cNvPr>
           <p:cNvSpPr>
             <a:spLocks noGrp="1" noRot="1" noChangeAspect="1"/>
           </p:cNvSpPr>
@@ -1288,7 +1130,13 @@
       </p:sp>
       <p:sp>
         <p:nvSpPr>
-          <p:cNvPr id="3" name="Notes Placeholder 2"/>
+          <p:cNvPr id="3" name="Notes Placeholder 2">
+            <a:extLst>
+              <a:ext uri="{FF2B5EF4-FFF2-40B4-BE49-F238E27FC236}">
+                <a16:creationId xmlns:a16="http://schemas.microsoft.com/office/drawing/2014/main" id="{033C7ECC-B4FF-CE79-1000-510D97F63E1C}"/>
+              </a:ext>
+            </a:extLst>
+          </p:cNvPr>
           <p:cNvSpPr>
             <a:spLocks noGrp="1"/>
           </p:cNvSpPr>
@@ -1301,17 +1149,19 @@
           <a:bodyPr/>
           <a:lstStyle/>
           <a:p>
-            <a:r>
-              <a:rPr lang="en-US" dirty="0"/>
-              <a:t/>
-            </a:r>
             <a:endParaRPr lang="en-US" dirty="0"/>
           </a:p>
         </p:txBody>
       </p:sp>
       <p:sp>
         <p:nvSpPr>
-          <p:cNvPr id="4" name="Slide Number Placeholder 3"/>
+          <p:cNvPr id="4" name="Slide Number Placeholder 3">
+            <a:extLst>
+              <a:ext uri="{FF2B5EF4-FFF2-40B4-BE49-F238E27FC236}">
+                <a16:creationId xmlns:a16="http://schemas.microsoft.com/office/drawing/2014/main" id="{672053A9-02FF-21EF-37D0-30B03A56EF4A}"/>
+              </a:ext>
+            </a:extLst>
+          </p:cNvPr>
           <p:cNvSpPr>
             <a:spLocks noGrp="1"/>
           </p:cNvSpPr>
@@ -1335,7 +1185,7 @@
     </p:spTree>
     <p:extLst>
       <p:ext uri="{BB962C8B-B14F-4D97-AF65-F5344CB8AC3E}">
-        <p14:creationId xmlns:p14="http://schemas.microsoft.com/office/powerpoint/2010/main" val="1024086991"/>
+        <p14:creationId xmlns:p14="http://schemas.microsoft.com/office/powerpoint/2010/main" val="2042811141"/>
       </p:ext>
     </p:extLst>
   </p:cSld>
@@ -1378,6 +1228,11 @@
 <file path=ppt/slideMasters/slideMaster1.xml><?xml version="1.0" encoding="utf-8"?>
 <p:sldMaster xmlns:a="http://schemas.openxmlformats.org/drawingml/2006/main" xmlns:r="http://schemas.openxmlformats.org/officeDocument/2006/relationships" xmlns:p="http://schemas.openxmlformats.org/presentationml/2006/main">
   <p:cSld>
+    <p:bg>
+      <p:bgRef idx="1001">
+        <a:schemeClr val="bg1"/>
+      </p:bgRef>
+    </p:bg>
     <p:spTree>
       <p:nvGrpSpPr>
         <p:cNvPr id="1" name=""/>
@@ -1671,14 +1526,14 @@
       </p:grpSpPr>
       <p:pic>
         <p:nvPicPr>
-          <p:cNvPr id="2" name="Image 0" descr="C:\Users\a.abboud\Desktop\html unit\resources\week-03\scratch\assets\header.png">    </p:cNvPr>
+          <p:cNvPr id="2" name="Image 0" descr="C:\Users\a.abboud\Desktop\html unit\resources\week-03\scratch\assets\header.png"/>
           <p:cNvPicPr>
             <a:picLocks noChangeAspect="1"/>
           </p:cNvPicPr>
           <p:nvPr/>
         </p:nvPicPr>
         <p:blipFill>
-          <a:blip r:embed="rId1"/>
+          <a:blip r:embed="rId3"/>
           <a:stretch>
             <a:fillRect/>
           </a:stretch>
@@ -1695,14 +1550,14 @@
       </p:pic>
       <p:pic>
         <p:nvPicPr>
-          <p:cNvPr id="3" name="Image 1" descr="C:\Users\a.abboud\Desktop\html unit\resources\week-03\scratch\assets\footer.png">    </p:cNvPr>
+          <p:cNvPr id="3" name="Image 1" descr="C:\Users\a.abboud\Desktop\html unit\resources\week-03\scratch\assets\footer.png"/>
           <p:cNvPicPr>
             <a:picLocks noChangeAspect="1"/>
           </p:cNvPicPr>
           <p:nvPr/>
         </p:nvPicPr>
         <p:blipFill>
-          <a:blip r:embed="rId2"/>
+          <a:blip r:embed="rId4"/>
           <a:stretch>
             <a:fillRect/>
           </a:stretch>
@@ -1736,6 +1591,13 @@
           </a:solidFill>
           <a:ln/>
         </p:spPr>
+        <p:txBody>
+          <a:bodyPr/>
+          <a:lstStyle/>
+          <a:p>
+            <a:endParaRPr lang="en-US"/>
+          </a:p>
+        </p:txBody>
       </p:sp>
       <p:sp>
         <p:nvSpPr>
@@ -1756,6 +1618,13 @@
           </a:solidFill>
           <a:ln/>
         </p:spPr>
+        <p:txBody>
+          <a:bodyPr/>
+          <a:lstStyle/>
+          <a:p>
+            <a:endParaRPr lang="en-US"/>
+          </a:p>
+        </p:txBody>
       </p:sp>
       <p:sp>
         <p:nvSpPr>
@@ -1778,7 +1647,7 @@
           <a:bodyPr wrap="square" rtlCol="0" anchor="ctr"/>
           <a:lstStyle/>
           <a:p>
-            <a:pPr indent="0" marL="0">
+            <a:pPr marL="0" indent="0">
               <a:buNone/>
             </a:pPr>
             <a:r>
@@ -1817,7 +1686,7 @@
           <a:bodyPr wrap="square" rtlCol="0" anchor="ctr"/>
           <a:lstStyle/>
           <a:p>
-            <a:pPr indent="0" marL="0">
+            <a:pPr marL="0" indent="0">
               <a:buNone/>
             </a:pPr>
             <a:r>
@@ -1857,6 +1726,13 @@
             <a:prstDash val="solid"/>
           </a:ln>
         </p:spPr>
+        <p:txBody>
+          <a:bodyPr/>
+          <a:lstStyle/>
+          <a:p>
+            <a:endParaRPr lang="en-US"/>
+          </a:p>
+        </p:txBody>
       </p:sp>
       <p:sp>
         <p:nvSpPr>
@@ -1879,7 +1755,7 @@
           <a:bodyPr wrap="square" rtlCol="0" anchor="ctr"/>
           <a:lstStyle/>
           <a:p>
-            <a:pPr indent="0" marL="0">
+            <a:pPr marL="0" indent="0">
               <a:buNone/>
             </a:pPr>
             <a:r>
@@ -1906,6 +1782,483 @@
 </file>
 
 <file path=ppt/slides/slide10.xml><?xml version="1.0" encoding="utf-8"?>
+<p:sld xmlns:a="http://schemas.openxmlformats.org/drawingml/2006/main" xmlns:r="http://schemas.openxmlformats.org/officeDocument/2006/relationships" xmlns:p="http://schemas.openxmlformats.org/presentationml/2006/main">
+  <p:cSld name="Slide 9">
+    <p:spTree>
+      <p:nvGrpSpPr>
+        <p:cNvPr id="1" name=""/>
+        <p:cNvGrpSpPr/>
+        <p:nvPr/>
+      </p:nvGrpSpPr>
+      <p:grpSpPr>
+        <a:xfrm>
+          <a:off x="0" y="0"/>
+          <a:ext cx="0" cy="0"/>
+          <a:chOff x="0" y="0"/>
+          <a:chExt cx="0" cy="0"/>
+        </a:xfrm>
+      </p:grpSpPr>
+      <p:pic>
+        <p:nvPicPr>
+          <p:cNvPr id="2" name="Image 0" descr="C:\Users\a.abboud\Desktop\html unit\resources\week-03\scratch\assets\header.png"/>
+          <p:cNvPicPr>
+            <a:picLocks noChangeAspect="1"/>
+          </p:cNvPicPr>
+          <p:nvPr/>
+        </p:nvPicPr>
+        <p:blipFill>
+          <a:blip r:embed="rId3"/>
+          <a:stretch>
+            <a:fillRect/>
+          </a:stretch>
+        </p:blipFill>
+        <p:spPr>
+          <a:xfrm>
+            <a:off x="0" y="0"/>
+            <a:ext cx="9144000" cy="960120"/>
+          </a:xfrm>
+          <a:prstGeom prst="rect">
+            <a:avLst/>
+          </a:prstGeom>
+        </p:spPr>
+      </p:pic>
+      <p:pic>
+        <p:nvPicPr>
+          <p:cNvPr id="3" name="Image 1" descr="C:\Users\a.abboud\Desktop\html unit\resources\week-03\scratch\assets\footer.png"/>
+          <p:cNvPicPr>
+            <a:picLocks noChangeAspect="1"/>
+          </p:cNvPicPr>
+          <p:nvPr/>
+        </p:nvPicPr>
+        <p:blipFill>
+          <a:blip r:embed="rId4"/>
+          <a:stretch>
+            <a:fillRect/>
+          </a:stretch>
+        </p:blipFill>
+        <p:spPr>
+          <a:xfrm>
+            <a:off x="0" y="4572000"/>
+            <a:ext cx="9144000" cy="566928"/>
+          </a:xfrm>
+          <a:prstGeom prst="rect">
+            <a:avLst/>
+          </a:prstGeom>
+        </p:spPr>
+      </p:pic>
+      <p:sp>
+        <p:nvSpPr>
+          <p:cNvPr id="4" name="Shape 0"/>
+          <p:cNvSpPr/>
+          <p:nvPr/>
+        </p:nvSpPr>
+        <p:spPr>
+          <a:xfrm>
+            <a:off x="0" y="960120"/>
+            <a:ext cx="2377440" cy="3621024"/>
+          </a:xfrm>
+          <a:prstGeom prst="rect">
+            <a:avLst/>
+          </a:prstGeom>
+          <a:solidFill>
+            <a:srgbClr val="0E2841"/>
+          </a:solidFill>
+          <a:ln/>
+        </p:spPr>
+        <p:txBody>
+          <a:bodyPr/>
+          <a:lstStyle/>
+          <a:p>
+            <a:endParaRPr lang="en-US"/>
+          </a:p>
+        </p:txBody>
+      </p:sp>
+      <p:sp>
+        <p:nvSpPr>
+          <p:cNvPr id="5" name="Text 1"/>
+          <p:cNvSpPr/>
+          <p:nvPr/>
+        </p:nvSpPr>
+        <p:spPr>
+          <a:xfrm>
+            <a:off x="0" y="1143000"/>
+            <a:ext cx="2377440" cy="502920"/>
+          </a:xfrm>
+          <a:prstGeom prst="rect">
+            <a:avLst/>
+          </a:prstGeom>
+          <a:noFill/>
+          <a:ln/>
+        </p:spPr>
+        <p:txBody>
+          <a:bodyPr wrap="square" rtlCol="0" anchor="ctr"/>
+          <a:lstStyle/>
+          <a:p>
+            <a:pPr marL="0" indent="0" algn="ctr">
+              <a:buNone/>
+            </a:pPr>
+            <a:r>
+              <a:rPr lang="en-US" sz="1800" b="1" dirty="0">
+                <a:solidFill>
+                  <a:srgbClr val="FFFFFF"/>
+                </a:solidFill>
+                <a:latin typeface="Arial" pitchFamily="34" charset="0"/>
+                <a:ea typeface="Arial" pitchFamily="34" charset="-122"/>
+                <a:cs typeface="Arial" pitchFamily="34" charset="-120"/>
+              </a:rPr>
+              <a:t>LESSON CORE</a:t>
+            </a:r>
+            <a:endParaRPr lang="en-US" sz="1800" dirty="0"/>
+          </a:p>
+        </p:txBody>
+      </p:sp>
+      <p:sp>
+        <p:nvSpPr>
+          <p:cNvPr id="6" name="Text 2"/>
+          <p:cNvSpPr/>
+          <p:nvPr/>
+        </p:nvSpPr>
+        <p:spPr>
+          <a:xfrm>
+            <a:off x="228600" y="1691640"/>
+            <a:ext cx="1920240" cy="457200"/>
+          </a:xfrm>
+          <a:prstGeom prst="rect">
+            <a:avLst/>
+          </a:prstGeom>
+          <a:noFill/>
+          <a:ln/>
+        </p:spPr>
+        <p:txBody>
+          <a:bodyPr wrap="square" rtlCol="0" anchor="ctr"/>
+          <a:lstStyle/>
+          <a:p>
+            <a:pPr marL="0" indent="0" algn="ctr">
+              <a:buNone/>
+            </a:pPr>
+            <a:r>
+              <a:rPr lang="en-US" sz="1200" dirty="0">
+                <a:solidFill>
+                  <a:srgbClr val="CFE8F2"/>
+                </a:solidFill>
+                <a:latin typeface="Arial" pitchFamily="34" charset="0"/>
+                <a:ea typeface="Arial" pitchFamily="34" charset="-122"/>
+                <a:cs typeface="Arial" pitchFamily="34" charset="-120"/>
+              </a:rPr>
+              <a:t>Gradual Release of Responsibility</a:t>
+            </a:r>
+            <a:endParaRPr lang="en-US" sz="1200" dirty="0"/>
+          </a:p>
+        </p:txBody>
+      </p:sp>
+      <p:sp>
+        <p:nvSpPr>
+          <p:cNvPr id="7" name="Shape 3"/>
+          <p:cNvSpPr/>
+          <p:nvPr/>
+        </p:nvSpPr>
+        <p:spPr>
+          <a:xfrm>
+            <a:off x="320040" y="2194560"/>
+            <a:ext cx="1737360" cy="0"/>
+          </a:xfrm>
+          <a:prstGeom prst="line">
+            <a:avLst/>
+          </a:prstGeom>
+          <a:noFill/>
+          <a:ln w="9525">
+            <a:solidFill>
+              <a:srgbClr val="CFE8F2"/>
+            </a:solidFill>
+            <a:prstDash val="solid"/>
+          </a:ln>
+        </p:spPr>
+        <p:txBody>
+          <a:bodyPr/>
+          <a:lstStyle/>
+          <a:p>
+            <a:endParaRPr lang="en-US"/>
+          </a:p>
+        </p:txBody>
+      </p:sp>
+      <p:sp>
+        <p:nvSpPr>
+          <p:cNvPr id="8" name="Text 4"/>
+          <p:cNvSpPr/>
+          <p:nvPr/>
+        </p:nvSpPr>
+        <p:spPr>
+          <a:xfrm>
+            <a:off x="228600" y="2331720"/>
+            <a:ext cx="1920240" cy="365760"/>
+          </a:xfrm>
+          <a:prstGeom prst="rect">
+            <a:avLst/>
+          </a:prstGeom>
+          <a:noFill/>
+          <a:ln/>
+        </p:spPr>
+        <p:txBody>
+          <a:bodyPr wrap="square" rtlCol="0" anchor="ctr"/>
+          <a:lstStyle/>
+          <a:p>
+            <a:pPr marL="0" indent="0" algn="ctr">
+              <a:buNone/>
+            </a:pPr>
+            <a:r>
+              <a:rPr lang="en-US" sz="1100" b="1" dirty="0">
+                <a:solidFill>
+                  <a:srgbClr val="CFE8F2"/>
+                </a:solidFill>
+                <a:latin typeface="Arial" pitchFamily="34" charset="0"/>
+                <a:ea typeface="Arial" pitchFamily="34" charset="-122"/>
+                <a:cs typeface="Arial" pitchFamily="34" charset="-120"/>
+              </a:rPr>
+              <a:t>30 - 40 minutes</a:t>
+            </a:r>
+            <a:endParaRPr lang="en-US" sz="1100" dirty="0"/>
+          </a:p>
+        </p:txBody>
+      </p:sp>
+      <p:sp>
+        <p:nvSpPr>
+          <p:cNvPr id="9" name="Text 5"/>
+          <p:cNvSpPr/>
+          <p:nvPr/>
+        </p:nvSpPr>
+        <p:spPr>
+          <a:xfrm>
+            <a:off x="228600" y="4114800"/>
+            <a:ext cx="1920240" cy="320040"/>
+          </a:xfrm>
+          <a:prstGeom prst="rect">
+            <a:avLst/>
+          </a:prstGeom>
+          <a:noFill/>
+          <a:ln/>
+        </p:spPr>
+        <p:txBody>
+          <a:bodyPr wrap="square" rtlCol="0" anchor="ctr"/>
+          <a:lstStyle/>
+          <a:p>
+            <a:pPr marL="0" indent="0" algn="ctr">
+              <a:buNone/>
+            </a:pPr>
+            <a:r>
+              <a:rPr lang="en-US" sz="1100" dirty="0">
+                <a:solidFill>
+                  <a:srgbClr val="CFE8F2"/>
+                </a:solidFill>
+                <a:latin typeface="Arial" pitchFamily="34" charset="0"/>
+                <a:ea typeface="Arial" pitchFamily="34" charset="-122"/>
+                <a:cs typeface="Arial" pitchFamily="34" charset="-120"/>
+              </a:rPr>
+              <a:t>3 / 3</a:t>
+            </a:r>
+            <a:endParaRPr lang="en-US" sz="1100" dirty="0"/>
+          </a:p>
+        </p:txBody>
+      </p:sp>
+      <p:sp>
+        <p:nvSpPr>
+          <p:cNvPr id="10" name="Shape 6"/>
+          <p:cNvSpPr/>
+          <p:nvPr/>
+        </p:nvSpPr>
+        <p:spPr>
+          <a:xfrm>
+            <a:off x="2651760" y="1097280"/>
+            <a:ext cx="6217920" cy="3337560"/>
+          </a:xfrm>
+          <a:prstGeom prst="rect">
+            <a:avLst/>
+          </a:prstGeom>
+          <a:solidFill>
+            <a:srgbClr val="EEF6FB"/>
+          </a:solidFill>
+          <a:ln/>
+        </p:spPr>
+        <p:txBody>
+          <a:bodyPr/>
+          <a:lstStyle/>
+          <a:p>
+            <a:endParaRPr lang="en-US"/>
+          </a:p>
+        </p:txBody>
+      </p:sp>
+      <p:sp>
+        <p:nvSpPr>
+          <p:cNvPr id="11" name="Text 7"/>
+          <p:cNvSpPr/>
+          <p:nvPr/>
+        </p:nvSpPr>
+        <p:spPr>
+          <a:xfrm>
+            <a:off x="2880360" y="1280160"/>
+            <a:ext cx="3163824" cy="2971800"/>
+          </a:xfrm>
+          <a:prstGeom prst="rect">
+            <a:avLst/>
+          </a:prstGeom>
+          <a:noFill/>
+          <a:ln/>
+        </p:spPr>
+        <p:txBody>
+          <a:bodyPr wrap="square" rtlCol="0" anchor="t"/>
+          <a:lstStyle/>
+          <a:p>
+            <a:pPr marL="342900" indent="-342900">
+              <a:lnSpc>
+                <a:spcPts val="2000"/>
+              </a:lnSpc>
+              <a:spcAft>
+                <a:spcPts val="800"/>
+              </a:spcAft>
+              <a:buSzPct val="100000"/>
+              <a:buChar char="●"/>
+            </a:pPr>
+            <a:r>
+              <a:rPr lang="en-US" sz="1500" b="1" dirty="0">
+                <a:solidFill>
+                  <a:srgbClr val="1A1A1A"/>
+                </a:solidFill>
+                <a:latin typeface="Arial" pitchFamily="34" charset="0"/>
+                <a:ea typeface="Arial" pitchFamily="34" charset="-122"/>
+                <a:cs typeface="Arial" pitchFamily="34" charset="-120"/>
+              </a:rPr>
+              <a:t>You Do: Code the Healthy Food Page</a:t>
+            </a:r>
+            <a:endParaRPr lang="en-US" sz="1500" dirty="0"/>
+          </a:p>
+          <a:p>
+            <a:pPr marL="0" indent="0">
+              <a:lnSpc>
+                <a:spcPts val="2000"/>
+              </a:lnSpc>
+              <a:spcAft>
+                <a:spcPts val="600"/>
+              </a:spcAft>
+              <a:buNone/>
+            </a:pPr>
+            <a:r>
+              <a:rPr lang="en-US" sz="1500" dirty="0">
+                <a:solidFill>
+                  <a:srgbClr val="1A1A1A"/>
+                </a:solidFill>
+                <a:latin typeface="Arial" pitchFamily="34" charset="0"/>
+                <a:ea typeface="Arial" pitchFamily="34" charset="-122"/>
+                <a:cs typeface="Arial" pitchFamily="34" charset="-120"/>
+              </a:rPr>
+              <a:t>You're given the finished webpage - write the HTML code that would build it, using the right heading and paragraph tags.</a:t>
+            </a:r>
+            <a:endParaRPr lang="en-US" sz="1500" dirty="0"/>
+          </a:p>
+        </p:txBody>
+      </p:sp>
+      <p:sp>
+        <p:nvSpPr>
+          <p:cNvPr id="12" name="Text 8"/>
+          <p:cNvSpPr/>
+          <p:nvPr/>
+        </p:nvSpPr>
+        <p:spPr>
+          <a:xfrm>
+            <a:off x="6236208" y="1280160"/>
+            <a:ext cx="2404872" cy="384048"/>
+          </a:xfrm>
+          <a:prstGeom prst="rect">
+            <a:avLst/>
+          </a:prstGeom>
+          <a:noFill/>
+          <a:ln/>
+        </p:spPr>
+        <p:txBody>
+          <a:bodyPr wrap="square" rtlCol="0" anchor="t"/>
+          <a:lstStyle/>
+          <a:p>
+            <a:pPr marL="0" indent="0">
+              <a:buNone/>
+            </a:pPr>
+            <a:r>
+              <a:rPr lang="en-US" sz="1050" i="1" dirty="0">
+                <a:solidFill>
+                  <a:srgbClr val="6B7785"/>
+                </a:solidFill>
+                <a:latin typeface="Arial" pitchFamily="34" charset="0"/>
+                <a:ea typeface="Arial" pitchFamily="34" charset="-122"/>
+                <a:cs typeface="Arial" pitchFamily="34" charset="-120"/>
+              </a:rPr>
+              <a:t>Activity: Code This Page - Healthy Food</a:t>
+            </a:r>
+            <a:endParaRPr lang="en-US" sz="1050" dirty="0"/>
+          </a:p>
+        </p:txBody>
+      </p:sp>
+      <p:sp>
+        <p:nvSpPr>
+          <p:cNvPr id="13" name="Shape 9"/>
+          <p:cNvSpPr/>
+          <p:nvPr/>
+        </p:nvSpPr>
+        <p:spPr>
+          <a:xfrm>
+            <a:off x="6236208" y="1700784"/>
+            <a:ext cx="2404872" cy="2551176"/>
+          </a:xfrm>
+          <a:prstGeom prst="rect">
+            <a:avLst/>
+          </a:prstGeom>
+          <a:solidFill>
+            <a:srgbClr val="FFFFFF"/>
+          </a:solidFill>
+          <a:ln w="12700">
+            <a:solidFill>
+              <a:srgbClr val="D8E4EC"/>
+            </a:solidFill>
+            <a:prstDash val="solid"/>
+          </a:ln>
+        </p:spPr>
+        <p:txBody>
+          <a:bodyPr/>
+          <a:lstStyle/>
+          <a:p>
+            <a:endParaRPr lang="en-US"/>
+          </a:p>
+        </p:txBody>
+      </p:sp>
+      <p:pic>
+        <p:nvPicPr>
+          <p:cNvPr id="14" name="Image 2" descr="C:\Users\a.abboud\Desktop\html unit\resources\week-03\scratch\assets\W3L1 - Code This Page - Healthy Food_cropped.png"/>
+          <p:cNvPicPr>
+            <a:picLocks noChangeAspect="1"/>
+          </p:cNvPicPr>
+          <p:nvPr/>
+        </p:nvPicPr>
+        <p:blipFill>
+          <a:blip r:embed="rId5"/>
+          <a:stretch>
+            <a:fillRect/>
+          </a:stretch>
+        </p:blipFill>
+        <p:spPr>
+          <a:xfrm>
+            <a:off x="6546822" y="1792224"/>
+            <a:ext cx="1783643" cy="2368296"/>
+          </a:xfrm>
+          <a:prstGeom prst="rect">
+            <a:avLst/>
+          </a:prstGeom>
+        </p:spPr>
+      </p:pic>
+    </p:spTree>
+  </p:cSld>
+  <p:clrMapOvr>
+    <a:masterClrMapping/>
+  </p:clrMapOvr>
+</p:sld>
+</file>
+
+<file path=ppt/slides/slide11.xml><?xml version="1.0" encoding="utf-8"?>
 <p:sld xmlns:a="http://schemas.openxmlformats.org/drawingml/2006/main" xmlns:r="http://schemas.openxmlformats.org/officeDocument/2006/relationships" xmlns:p="http://schemas.openxmlformats.org/presentationml/2006/main">
   <p:cSld name="Slide 10">
     <p:spTree>
@@ -1924,14 +2277,14 @@
       </p:grpSpPr>
       <p:pic>
         <p:nvPicPr>
-          <p:cNvPr id="2" name="Image 0" descr="C:\Users\a.abboud\Desktop\html unit\resources\week-03\scratch\assets\header.png">    </p:cNvPr>
+          <p:cNvPr id="2" name="Image 0" descr="C:\Users\a.abboud\Desktop\html unit\resources\week-03\scratch\assets\header.png"/>
           <p:cNvPicPr>
             <a:picLocks noChangeAspect="1"/>
           </p:cNvPicPr>
           <p:nvPr/>
         </p:nvPicPr>
         <p:blipFill>
-          <a:blip r:embed="rId1"/>
+          <a:blip r:embed="rId3"/>
           <a:stretch>
             <a:fillRect/>
           </a:stretch>
@@ -1948,14 +2301,14 @@
       </p:pic>
       <p:pic>
         <p:nvPicPr>
-          <p:cNvPr id="3" name="Image 1" descr="C:\Users\a.abboud\Desktop\html unit\resources\week-03\scratch\assets\footer.png">    </p:cNvPr>
+          <p:cNvPr id="3" name="Image 1" descr="C:\Users\a.abboud\Desktop\html unit\resources\week-03\scratch\assets\footer.png"/>
           <p:cNvPicPr>
             <a:picLocks noChangeAspect="1"/>
           </p:cNvPicPr>
           <p:nvPr/>
         </p:nvPicPr>
         <p:blipFill>
-          <a:blip r:embed="rId2"/>
+          <a:blip r:embed="rId4"/>
           <a:stretch>
             <a:fillRect/>
           </a:stretch>
@@ -1989,6 +2342,13 @@
           </a:solidFill>
           <a:ln/>
         </p:spPr>
+        <p:txBody>
+          <a:bodyPr/>
+          <a:lstStyle/>
+          <a:p>
+            <a:endParaRPr lang="en-US"/>
+          </a:p>
+        </p:txBody>
       </p:sp>
       <p:sp>
         <p:nvSpPr>
@@ -2011,7 +2371,7 @@
           <a:bodyPr wrap="square" rtlCol="0" anchor="ctr"/>
           <a:lstStyle/>
           <a:p>
-            <a:pPr algn="ctr" indent="0" marL="0">
+            <a:pPr marL="0" indent="0" algn="ctr">
               <a:buNone/>
             </a:pPr>
             <a:r>
@@ -2050,7 +2410,7 @@
           <a:bodyPr wrap="square" rtlCol="0" anchor="ctr"/>
           <a:lstStyle/>
           <a:p>
-            <a:pPr algn="ctr" indent="0" marL="0">
+            <a:pPr marL="0" indent="0" algn="ctr">
               <a:buNone/>
             </a:pPr>
             <a:r>
@@ -2090,6 +2450,13 @@
             <a:prstDash val="solid"/>
           </a:ln>
         </p:spPr>
+        <p:txBody>
+          <a:bodyPr/>
+          <a:lstStyle/>
+          <a:p>
+            <a:endParaRPr lang="en-US"/>
+          </a:p>
+        </p:txBody>
       </p:sp>
       <p:sp>
         <p:nvSpPr>
@@ -2112,7 +2479,7 @@
           <a:bodyPr wrap="square" rtlCol="0" anchor="ctr"/>
           <a:lstStyle/>
           <a:p>
-            <a:pPr algn="ctr" indent="0" marL="0">
+            <a:pPr marL="0" indent="0" algn="ctr">
               <a:buNone/>
             </a:pPr>
             <a:r>
@@ -2149,6 +2516,13 @@
           </a:solidFill>
           <a:ln/>
         </p:spPr>
+        <p:txBody>
+          <a:bodyPr/>
+          <a:lstStyle/>
+          <a:p>
+            <a:endParaRPr lang="en-US"/>
+          </a:p>
+        </p:txBody>
       </p:sp>
       <p:sp>
         <p:nvSpPr>
@@ -2195,7 +2569,7 @@
             <a:endParaRPr lang="en-US" sz="1800" dirty="0"/>
           </a:p>
           <a:p>
-            <a:pPr indent="0" marL="0">
+            <a:pPr marL="0" indent="0">
               <a:lnSpc>
                 <a:spcPts val="2600"/>
               </a:lnSpc>
@@ -2218,7 +2592,7 @@
             <a:endParaRPr lang="en-US" sz="1800" dirty="0"/>
           </a:p>
           <a:p>
-            <a:pPr indent="0" marL="0">
+            <a:pPr marL="0" indent="0">
               <a:lnSpc>
                 <a:spcPts val="2600"/>
               </a:lnSpc>
@@ -2269,14 +2643,14 @@
       </p:grpSpPr>
       <p:pic>
         <p:nvPicPr>
-          <p:cNvPr id="2" name="Image 0" descr="C:\Users\a.abboud\Desktop\html unit\resources\week-03\scratch\assets\header.png">    </p:cNvPr>
+          <p:cNvPr id="2" name="Image 0" descr="C:\Users\a.abboud\Desktop\html unit\resources\week-03\scratch\assets\header.png"/>
           <p:cNvPicPr>
             <a:picLocks noChangeAspect="1"/>
           </p:cNvPicPr>
           <p:nvPr/>
         </p:nvPicPr>
         <p:blipFill>
-          <a:blip r:embed="rId1"/>
+          <a:blip r:embed="rId3"/>
           <a:stretch>
             <a:fillRect/>
           </a:stretch>
@@ -2293,14 +2667,14 @@
       </p:pic>
       <p:pic>
         <p:nvPicPr>
-          <p:cNvPr id="3" name="Image 1" descr="C:\Users\a.abboud\Desktop\html unit\resources\week-03\scratch\assets\footer.png">    </p:cNvPr>
+          <p:cNvPr id="3" name="Image 1" descr="C:\Users\a.abboud\Desktop\html unit\resources\week-03\scratch\assets\footer.png"/>
           <p:cNvPicPr>
             <a:picLocks noChangeAspect="1"/>
           </p:cNvPicPr>
           <p:nvPr/>
         </p:nvPicPr>
         <p:blipFill>
-          <a:blip r:embed="rId2"/>
+          <a:blip r:embed="rId4"/>
           <a:stretch>
             <a:fillRect/>
           </a:stretch>
@@ -2334,6 +2708,13 @@
           </a:solidFill>
           <a:ln/>
         </p:spPr>
+        <p:txBody>
+          <a:bodyPr/>
+          <a:lstStyle/>
+          <a:p>
+            <a:endParaRPr lang="en-US"/>
+          </a:p>
+        </p:txBody>
       </p:sp>
       <p:sp>
         <p:nvSpPr>
@@ -2356,7 +2737,7 @@
           <a:bodyPr wrap="square" rtlCol="0" anchor="ctr"/>
           <a:lstStyle/>
           <a:p>
-            <a:pPr indent="0" marL="0">
+            <a:pPr marL="0" indent="0">
               <a:buNone/>
             </a:pPr>
             <a:r>
@@ -2393,6 +2774,13 @@
           </a:solidFill>
           <a:ln/>
         </p:spPr>
+        <p:txBody>
+          <a:bodyPr/>
+          <a:lstStyle/>
+          <a:p>
+            <a:endParaRPr lang="en-US"/>
+          </a:p>
+        </p:txBody>
       </p:sp>
       <p:sp>
         <p:nvSpPr>
@@ -2413,6 +2801,13 @@
           </a:solidFill>
           <a:ln/>
         </p:spPr>
+        <p:txBody>
+          <a:bodyPr/>
+          <a:lstStyle/>
+          <a:p>
+            <a:endParaRPr lang="en-US"/>
+          </a:p>
+        </p:txBody>
       </p:sp>
       <p:sp>
         <p:nvSpPr>
@@ -2435,7 +2830,7 @@
           <a:bodyPr wrap="square" rtlCol="0" anchor="ctr"/>
           <a:lstStyle/>
           <a:p>
-            <a:pPr algn="ctr" indent="0" marL="0">
+            <a:pPr marL="0" indent="0" algn="ctr">
               <a:buNone/>
             </a:pPr>
             <a:r>
@@ -2542,6 +2937,13 @@
           </a:solidFill>
           <a:ln/>
         </p:spPr>
+        <p:txBody>
+          <a:bodyPr/>
+          <a:lstStyle/>
+          <a:p>
+            <a:endParaRPr lang="en-US"/>
+          </a:p>
+        </p:txBody>
       </p:sp>
       <p:sp>
         <p:nvSpPr>
@@ -2562,6 +2964,13 @@
           </a:solidFill>
           <a:ln/>
         </p:spPr>
+        <p:txBody>
+          <a:bodyPr/>
+          <a:lstStyle/>
+          <a:p>
+            <a:endParaRPr lang="en-US"/>
+          </a:p>
+        </p:txBody>
       </p:sp>
       <p:sp>
         <p:nvSpPr>
@@ -2584,7 +2993,7 @@
           <a:bodyPr wrap="square" rtlCol="0" anchor="ctr"/>
           <a:lstStyle/>
           <a:p>
-            <a:pPr algn="ctr" indent="0" marL="0">
+            <a:pPr marL="0" indent="0" algn="ctr">
               <a:buNone/>
             </a:pPr>
             <a:r>
@@ -2699,14 +3108,14 @@
       </p:grpSpPr>
       <p:pic>
         <p:nvPicPr>
-          <p:cNvPr id="2" name="Image 0" descr="C:\Users\a.abboud\Desktop\html unit\resources\week-03\scratch\assets\header.png">    </p:cNvPr>
+          <p:cNvPr id="2" name="Image 0" descr="C:\Users\a.abboud\Desktop\html unit\resources\week-03\scratch\assets\header.png"/>
           <p:cNvPicPr>
             <a:picLocks noChangeAspect="1"/>
           </p:cNvPicPr>
           <p:nvPr/>
         </p:nvPicPr>
         <p:blipFill>
-          <a:blip r:embed="rId1"/>
+          <a:blip r:embed="rId3"/>
           <a:stretch>
             <a:fillRect/>
           </a:stretch>
@@ -2723,14 +3132,14 @@
       </p:pic>
       <p:pic>
         <p:nvPicPr>
-          <p:cNvPr id="3" name="Image 1" descr="C:\Users\a.abboud\Desktop\html unit\resources\week-03\scratch\assets\footer.png">    </p:cNvPr>
+          <p:cNvPr id="3" name="Image 1" descr="C:\Users\a.abboud\Desktop\html unit\resources\week-03\scratch\assets\footer.png"/>
           <p:cNvPicPr>
             <a:picLocks noChangeAspect="1"/>
           </p:cNvPicPr>
           <p:nvPr/>
         </p:nvPicPr>
         <p:blipFill>
-          <a:blip r:embed="rId2"/>
+          <a:blip r:embed="rId4"/>
           <a:stretch>
             <a:fillRect/>
           </a:stretch>
@@ -2764,6 +3173,13 @@
           </a:solidFill>
           <a:ln/>
         </p:spPr>
+        <p:txBody>
+          <a:bodyPr/>
+          <a:lstStyle/>
+          <a:p>
+            <a:endParaRPr lang="en-US"/>
+          </a:p>
+        </p:txBody>
       </p:sp>
       <p:sp>
         <p:nvSpPr>
@@ -2786,7 +3202,7 @@
           <a:bodyPr wrap="square" rtlCol="0" anchor="ctr"/>
           <a:lstStyle/>
           <a:p>
-            <a:pPr indent="0" marL="0">
+            <a:pPr marL="0" indent="0">
               <a:buNone/>
             </a:pPr>
             <a:r>
@@ -2823,6 +3239,13 @@
           </a:solidFill>
           <a:ln/>
         </p:spPr>
+        <p:txBody>
+          <a:bodyPr/>
+          <a:lstStyle/>
+          <a:p>
+            <a:endParaRPr lang="en-US"/>
+          </a:p>
+        </p:txBody>
       </p:sp>
       <p:sp>
         <p:nvSpPr>
@@ -2843,6 +3266,13 @@
           </a:solidFill>
           <a:ln/>
         </p:spPr>
+        <p:txBody>
+          <a:bodyPr/>
+          <a:lstStyle/>
+          <a:p>
+            <a:endParaRPr lang="en-US"/>
+          </a:p>
+        </p:txBody>
       </p:sp>
       <p:sp>
         <p:nvSpPr>
@@ -2865,7 +3295,7 @@
           <a:bodyPr wrap="square" rtlCol="0" anchor="ctr"/>
           <a:lstStyle/>
           <a:p>
-            <a:pPr indent="0" marL="0">
+            <a:pPr marL="0" indent="0">
               <a:buNone/>
             </a:pPr>
             <a:r>
@@ -2904,7 +3334,7 @@
           <a:bodyPr wrap="square" rtlCol="0" anchor="t"/>
           <a:lstStyle/>
           <a:p>
-            <a:pPr indent="0" marL="0">
+            <a:pPr marL="0" indent="0">
               <a:lnSpc>
                 <a:spcPts val="1500"/>
               </a:lnSpc>
@@ -2944,6 +3374,13 @@
           </a:solidFill>
           <a:ln/>
         </p:spPr>
+        <p:txBody>
+          <a:bodyPr/>
+          <a:lstStyle/>
+          <a:p>
+            <a:endParaRPr lang="en-US"/>
+          </a:p>
+        </p:txBody>
       </p:sp>
       <p:sp>
         <p:nvSpPr>
@@ -2964,6 +3401,13 @@
           </a:solidFill>
           <a:ln/>
         </p:spPr>
+        <p:txBody>
+          <a:bodyPr/>
+          <a:lstStyle/>
+          <a:p>
+            <a:endParaRPr lang="en-US"/>
+          </a:p>
+        </p:txBody>
       </p:sp>
       <p:sp>
         <p:nvSpPr>
@@ -2986,7 +3430,7 @@
           <a:bodyPr wrap="square" rtlCol="0" anchor="ctr"/>
           <a:lstStyle/>
           <a:p>
-            <a:pPr indent="0" marL="0">
+            <a:pPr marL="0" indent="0">
               <a:buNone/>
             </a:pPr>
             <a:r>
@@ -3025,7 +3469,7 @@
           <a:bodyPr wrap="square" rtlCol="0" anchor="t"/>
           <a:lstStyle/>
           <a:p>
-            <a:pPr indent="0" marL="0">
+            <a:pPr marL="0" indent="0">
               <a:lnSpc>
                 <a:spcPts val="1500"/>
               </a:lnSpc>
@@ -3065,6 +3509,13 @@
           </a:solidFill>
           <a:ln/>
         </p:spPr>
+        <p:txBody>
+          <a:bodyPr/>
+          <a:lstStyle/>
+          <a:p>
+            <a:endParaRPr lang="en-US"/>
+          </a:p>
+        </p:txBody>
       </p:sp>
       <p:sp>
         <p:nvSpPr>
@@ -3085,6 +3536,13 @@
           </a:solidFill>
           <a:ln/>
         </p:spPr>
+        <p:txBody>
+          <a:bodyPr/>
+          <a:lstStyle/>
+          <a:p>
+            <a:endParaRPr lang="en-US"/>
+          </a:p>
+        </p:txBody>
       </p:sp>
       <p:sp>
         <p:nvSpPr>
@@ -3107,7 +3565,7 @@
           <a:bodyPr wrap="square" rtlCol="0" anchor="ctr"/>
           <a:lstStyle/>
           <a:p>
-            <a:pPr indent="0" marL="0">
+            <a:pPr marL="0" indent="0">
               <a:buNone/>
             </a:pPr>
             <a:r>
@@ -3146,7 +3604,7 @@
           <a:bodyPr wrap="square" rtlCol="0" anchor="t"/>
           <a:lstStyle/>
           <a:p>
-            <a:pPr indent="0" marL="0">
+            <a:pPr marL="0" indent="0">
               <a:lnSpc>
                 <a:spcPts val="1500"/>
               </a:lnSpc>
@@ -3194,14 +3652,14 @@
       </p:grpSpPr>
       <p:pic>
         <p:nvPicPr>
-          <p:cNvPr id="2" name="Image 0" descr="C:\Users\a.abboud\Desktop\html unit\resources\week-03\scratch\assets\header.png">    </p:cNvPr>
+          <p:cNvPr id="2" name="Image 0" descr="C:\Users\a.abboud\Desktop\html unit\resources\week-03\scratch\assets\header.png"/>
           <p:cNvPicPr>
             <a:picLocks noChangeAspect="1"/>
           </p:cNvPicPr>
           <p:nvPr/>
         </p:nvPicPr>
         <p:blipFill>
-          <a:blip r:embed="rId1"/>
+          <a:blip r:embed="rId3"/>
           <a:stretch>
             <a:fillRect/>
           </a:stretch>
@@ -3218,14 +3676,14 @@
       </p:pic>
       <p:pic>
         <p:nvPicPr>
-          <p:cNvPr id="3" name="Image 1" descr="C:\Users\a.abboud\Desktop\html unit\resources\week-03\scratch\assets\footer.png">    </p:cNvPr>
+          <p:cNvPr id="3" name="Image 1" descr="C:\Users\a.abboud\Desktop\html unit\resources\week-03\scratch\assets\footer.png"/>
           <p:cNvPicPr>
             <a:picLocks noChangeAspect="1"/>
           </p:cNvPicPr>
           <p:nvPr/>
         </p:nvPicPr>
         <p:blipFill>
-          <a:blip r:embed="rId2"/>
+          <a:blip r:embed="rId4"/>
           <a:stretch>
             <a:fillRect/>
           </a:stretch>
@@ -3259,6 +3717,13 @@
           </a:solidFill>
           <a:ln/>
         </p:spPr>
+        <p:txBody>
+          <a:bodyPr/>
+          <a:lstStyle/>
+          <a:p>
+            <a:endParaRPr lang="en-US"/>
+          </a:p>
+        </p:txBody>
       </p:sp>
       <p:sp>
         <p:nvSpPr>
@@ -3281,7 +3746,7 @@
           <a:bodyPr wrap="square" rtlCol="0" anchor="ctr"/>
           <a:lstStyle/>
           <a:p>
-            <a:pPr indent="0" marL="0">
+            <a:pPr marL="0" indent="0">
               <a:buNone/>
             </a:pPr>
             <a:r>
@@ -3318,6 +3783,13 @@
           </a:solidFill>
           <a:ln/>
         </p:spPr>
+        <p:txBody>
+          <a:bodyPr/>
+          <a:lstStyle/>
+          <a:p>
+            <a:endParaRPr lang="en-US"/>
+          </a:p>
+        </p:txBody>
       </p:sp>
       <p:sp>
         <p:nvSpPr>
@@ -3338,6 +3810,13 @@
           </a:solidFill>
           <a:ln/>
         </p:spPr>
+        <p:txBody>
+          <a:bodyPr/>
+          <a:lstStyle/>
+          <a:p>
+            <a:endParaRPr lang="en-US"/>
+          </a:p>
+        </p:txBody>
       </p:sp>
       <p:sp>
         <p:nvSpPr>
@@ -3360,7 +3839,7 @@
           <a:bodyPr wrap="square" rtlCol="0" anchor="ctr"/>
           <a:lstStyle/>
           <a:p>
-            <a:pPr algn="ctr" indent="0" marL="0">
+            <a:pPr marL="0" indent="0" algn="ctr">
               <a:buNone/>
             </a:pPr>
             <a:r>
@@ -3399,7 +3878,7 @@
           <a:bodyPr wrap="square" rtlCol="0" anchor="t"/>
           <a:lstStyle/>
           <a:p>
-            <a:pPr indent="0" marL="0">
+            <a:pPr marL="0" indent="0">
               <a:buNone/>
             </a:pPr>
             <a:r>
@@ -3436,6 +3915,13 @@
           </a:solidFill>
           <a:ln/>
         </p:spPr>
+        <p:txBody>
+          <a:bodyPr/>
+          <a:lstStyle/>
+          <a:p>
+            <a:endParaRPr lang="en-US"/>
+          </a:p>
+        </p:txBody>
       </p:sp>
       <p:sp>
         <p:nvSpPr>
@@ -3456,6 +3942,13 @@
           </a:solidFill>
           <a:ln/>
         </p:spPr>
+        <p:txBody>
+          <a:bodyPr/>
+          <a:lstStyle/>
+          <a:p>
+            <a:endParaRPr lang="en-US"/>
+          </a:p>
+        </p:txBody>
       </p:sp>
       <p:sp>
         <p:nvSpPr>
@@ -3478,7 +3971,7 @@
           <a:bodyPr wrap="square" rtlCol="0" anchor="ctr"/>
           <a:lstStyle/>
           <a:p>
-            <a:pPr algn="ctr" indent="0" marL="0">
+            <a:pPr marL="0" indent="0" algn="ctr">
               <a:buNone/>
             </a:pPr>
             <a:r>
@@ -3517,7 +4010,7 @@
           <a:bodyPr wrap="square" rtlCol="0" anchor="t"/>
           <a:lstStyle/>
           <a:p>
-            <a:pPr indent="0" marL="0">
+            <a:pPr marL="0" indent="0">
               <a:buNone/>
             </a:pPr>
             <a:r>
@@ -3554,6 +4047,13 @@
           </a:solidFill>
           <a:ln/>
         </p:spPr>
+        <p:txBody>
+          <a:bodyPr/>
+          <a:lstStyle/>
+          <a:p>
+            <a:endParaRPr lang="en-US"/>
+          </a:p>
+        </p:txBody>
       </p:sp>
       <p:sp>
         <p:nvSpPr>
@@ -3574,6 +4074,13 @@
           </a:solidFill>
           <a:ln/>
         </p:spPr>
+        <p:txBody>
+          <a:bodyPr/>
+          <a:lstStyle/>
+          <a:p>
+            <a:endParaRPr lang="en-US"/>
+          </a:p>
+        </p:txBody>
       </p:sp>
       <p:sp>
         <p:nvSpPr>
@@ -3596,7 +4103,7 @@
           <a:bodyPr wrap="square" rtlCol="0" anchor="ctr"/>
           <a:lstStyle/>
           <a:p>
-            <a:pPr algn="ctr" indent="0" marL="0">
+            <a:pPr marL="0" indent="0" algn="ctr">
               <a:buNone/>
             </a:pPr>
             <a:r>
@@ -3635,7 +4142,7 @@
           <a:bodyPr wrap="square" rtlCol="0" anchor="t"/>
           <a:lstStyle/>
           <a:p>
-            <a:pPr indent="0" marL="0">
+            <a:pPr marL="0" indent="0">
               <a:buNone/>
             </a:pPr>
             <a:r>
@@ -3652,7 +4159,7 @@
             <a:endParaRPr lang="en-US" sz="1300" dirty="0"/>
           </a:p>
           <a:p>
-            <a:pPr indent="0" marL="0">
+            <a:pPr marL="0" indent="0">
               <a:buNone/>
             </a:pPr>
             <a:r>
@@ -3669,7 +4176,7 @@
             <a:endParaRPr lang="en-US" sz="1300" dirty="0"/>
           </a:p>
           <a:p>
-            <a:pPr indent="0" marL="0">
+            <a:pPr marL="0" indent="0">
               <a:buNone/>
             </a:pPr>
             <a:r>
@@ -3706,6 +4213,13 @@
           </a:solidFill>
           <a:ln/>
         </p:spPr>
+        <p:txBody>
+          <a:bodyPr/>
+          <a:lstStyle/>
+          <a:p>
+            <a:endParaRPr lang="en-US"/>
+          </a:p>
+        </p:txBody>
       </p:sp>
       <p:sp>
         <p:nvSpPr>
@@ -3726,6 +4240,13 @@
           </a:solidFill>
           <a:ln/>
         </p:spPr>
+        <p:txBody>
+          <a:bodyPr/>
+          <a:lstStyle/>
+          <a:p>
+            <a:endParaRPr lang="en-US"/>
+          </a:p>
+        </p:txBody>
       </p:sp>
       <p:sp>
         <p:nvSpPr>
@@ -3748,7 +4269,7 @@
           <a:bodyPr wrap="square" rtlCol="0" anchor="ctr"/>
           <a:lstStyle/>
           <a:p>
-            <a:pPr algn="ctr" indent="0" marL="0">
+            <a:pPr marL="0" indent="0" algn="ctr">
               <a:buNone/>
             </a:pPr>
             <a:r>
@@ -3787,7 +4308,7 @@
           <a:bodyPr wrap="square" rtlCol="0" anchor="t"/>
           <a:lstStyle/>
           <a:p>
-            <a:pPr indent="0" marL="0">
+            <a:pPr marL="0" indent="0">
               <a:buNone/>
             </a:pPr>
             <a:r>
@@ -3804,7 +4325,7 @@
             <a:endParaRPr lang="en-US" sz="1300" dirty="0"/>
           </a:p>
           <a:p>
-            <a:pPr indent="0" marL="0">
+            <a:pPr marL="0" indent="0">
               <a:buNone/>
             </a:pPr>
             <a:r>
@@ -3821,7 +4342,7 @@
             <a:endParaRPr lang="en-US" sz="1300" dirty="0"/>
           </a:p>
           <a:p>
-            <a:pPr indent="0" marL="0">
+            <a:pPr marL="0" indent="0">
               <a:buNone/>
             </a:pPr>
             <a:r>
@@ -3858,6 +4379,13 @@
           </a:solidFill>
           <a:ln/>
         </p:spPr>
+        <p:txBody>
+          <a:bodyPr/>
+          <a:lstStyle/>
+          <a:p>
+            <a:endParaRPr lang="en-US"/>
+          </a:p>
+        </p:txBody>
       </p:sp>
       <p:sp>
         <p:nvSpPr>
@@ -3880,7 +4408,7 @@
           <a:bodyPr wrap="square" rtlCol="0" anchor="ctr"/>
           <a:lstStyle/>
           <a:p>
-            <a:pPr algn="ctr" indent="0" marL="0">
+            <a:pPr marL="0" indent="0" algn="ctr">
               <a:buNone/>
             </a:pPr>
             <a:r>
@@ -3925,14 +4453,14 @@
       </p:grpSpPr>
       <p:pic>
         <p:nvPicPr>
-          <p:cNvPr id="2" name="Image 0" descr="C:\Users\a.abboud\Desktop\html unit\resources\week-03\scratch\assets\header.png">    </p:cNvPr>
+          <p:cNvPr id="2" name="Image 0" descr="C:\Users\a.abboud\Desktop\html unit\resources\week-03\scratch\assets\header.png"/>
           <p:cNvPicPr>
             <a:picLocks noChangeAspect="1"/>
           </p:cNvPicPr>
           <p:nvPr/>
         </p:nvPicPr>
         <p:blipFill>
-          <a:blip r:embed="rId1"/>
+          <a:blip r:embed="rId3"/>
           <a:stretch>
             <a:fillRect/>
           </a:stretch>
@@ -3949,14 +4477,14 @@
       </p:pic>
       <p:pic>
         <p:nvPicPr>
-          <p:cNvPr id="3" name="Image 1" descr="C:\Users\a.abboud\Desktop\html unit\resources\week-03\scratch\assets\footer.png">    </p:cNvPr>
+          <p:cNvPr id="3" name="Image 1" descr="C:\Users\a.abboud\Desktop\html unit\resources\week-03\scratch\assets\footer.png"/>
           <p:cNvPicPr>
             <a:picLocks noChangeAspect="1"/>
           </p:cNvPicPr>
           <p:nvPr/>
         </p:nvPicPr>
         <p:blipFill>
-          <a:blip r:embed="rId2"/>
+          <a:blip r:embed="rId4"/>
           <a:stretch>
             <a:fillRect/>
           </a:stretch>
@@ -3990,6 +4518,13 @@
           </a:solidFill>
           <a:ln/>
         </p:spPr>
+        <p:txBody>
+          <a:bodyPr/>
+          <a:lstStyle/>
+          <a:p>
+            <a:endParaRPr lang="en-US"/>
+          </a:p>
+        </p:txBody>
       </p:sp>
       <p:sp>
         <p:nvSpPr>
@@ -4012,7 +4547,7 @@
           <a:bodyPr wrap="square" rtlCol="0" anchor="ctr"/>
           <a:lstStyle/>
           <a:p>
-            <a:pPr indent="0" marL="0">
+            <a:pPr marL="0" indent="0">
               <a:buNone/>
             </a:pPr>
             <a:r>
@@ -4049,6 +4584,13 @@
           </a:solidFill>
           <a:ln/>
         </p:spPr>
+        <p:txBody>
+          <a:bodyPr/>
+          <a:lstStyle/>
+          <a:p>
+            <a:endParaRPr lang="en-US"/>
+          </a:p>
+        </p:txBody>
       </p:sp>
       <p:sp>
         <p:nvSpPr>
@@ -4069,6 +4611,13 @@
           </a:solidFill>
           <a:ln/>
         </p:spPr>
+        <p:txBody>
+          <a:bodyPr/>
+          <a:lstStyle/>
+          <a:p>
+            <a:endParaRPr lang="en-US"/>
+          </a:p>
+        </p:txBody>
       </p:sp>
       <p:sp>
         <p:nvSpPr>
@@ -4089,6 +4638,13 @@
           </a:solidFill>
           <a:ln/>
         </p:spPr>
+        <p:txBody>
+          <a:bodyPr/>
+          <a:lstStyle/>
+          <a:p>
+            <a:endParaRPr lang="en-US"/>
+          </a:p>
+        </p:txBody>
       </p:sp>
       <p:sp>
         <p:nvSpPr>
@@ -4109,6 +4665,13 @@
           </a:solidFill>
           <a:ln/>
         </p:spPr>
+        <p:txBody>
+          <a:bodyPr/>
+          <a:lstStyle/>
+          <a:p>
+            <a:endParaRPr lang="en-US"/>
+          </a:p>
+        </p:txBody>
       </p:sp>
       <p:sp>
         <p:nvSpPr>
@@ -4129,6 +4692,13 @@
           </a:solidFill>
           <a:ln/>
         </p:spPr>
+        <p:txBody>
+          <a:bodyPr/>
+          <a:lstStyle/>
+          <a:p>
+            <a:endParaRPr lang="en-US"/>
+          </a:p>
+        </p:txBody>
       </p:sp>
       <p:sp>
         <p:nvSpPr>
@@ -4149,6 +4719,13 @@
           </a:solidFill>
           <a:ln/>
         </p:spPr>
+        <p:txBody>
+          <a:bodyPr/>
+          <a:lstStyle/>
+          <a:p>
+            <a:endParaRPr lang="en-US"/>
+          </a:p>
+        </p:txBody>
       </p:sp>
       <p:sp>
         <p:nvSpPr>
@@ -4171,7 +4748,7 @@
           <a:bodyPr wrap="square" rtlCol="0" anchor="t"/>
           <a:lstStyle/>
           <a:p>
-            <a:pPr indent="0" marL="0">
+            <a:pPr marL="0" indent="0">
               <a:lnSpc>
                 <a:spcPts val="2200"/>
               </a:lnSpc>
@@ -4219,14 +4796,14 @@
       </p:grpSpPr>
       <p:pic>
         <p:nvPicPr>
-          <p:cNvPr id="2" name="Image 0" descr="C:\Users\a.abboud\Desktop\html unit\resources\week-03\scratch\assets\header.png">    </p:cNvPr>
+          <p:cNvPr id="2" name="Image 0" descr="C:\Users\a.abboud\Desktop\html unit\resources\week-03\scratch\assets\header.png"/>
           <p:cNvPicPr>
             <a:picLocks noChangeAspect="1"/>
           </p:cNvPicPr>
           <p:nvPr/>
         </p:nvPicPr>
         <p:blipFill>
-          <a:blip r:embed="rId1"/>
+          <a:blip r:embed="rId3"/>
           <a:stretch>
             <a:fillRect/>
           </a:stretch>
@@ -4243,14 +4820,14 @@
       </p:pic>
       <p:pic>
         <p:nvPicPr>
-          <p:cNvPr id="3" name="Image 1" descr="C:\Users\a.abboud\Desktop\html unit\resources\week-03\scratch\assets\footer.png">    </p:cNvPr>
+          <p:cNvPr id="3" name="Image 1" descr="C:\Users\a.abboud\Desktop\html unit\resources\week-03\scratch\assets\footer.png"/>
           <p:cNvPicPr>
             <a:picLocks noChangeAspect="1"/>
           </p:cNvPicPr>
           <p:nvPr/>
         </p:nvPicPr>
         <p:blipFill>
-          <a:blip r:embed="rId2"/>
+          <a:blip r:embed="rId4"/>
           <a:stretch>
             <a:fillRect/>
           </a:stretch>
@@ -4284,6 +4861,13 @@
           </a:solidFill>
           <a:ln/>
         </p:spPr>
+        <p:txBody>
+          <a:bodyPr/>
+          <a:lstStyle/>
+          <a:p>
+            <a:endParaRPr lang="en-US"/>
+          </a:p>
+        </p:txBody>
       </p:sp>
       <p:sp>
         <p:nvSpPr>
@@ -4306,7 +4890,7 @@
           <a:bodyPr wrap="square" rtlCol="0" anchor="ctr"/>
           <a:lstStyle/>
           <a:p>
-            <a:pPr algn="ctr" indent="0" marL="0">
+            <a:pPr marL="0" indent="0" algn="ctr">
               <a:buNone/>
             </a:pPr>
             <a:r>
@@ -4345,7 +4929,7 @@
           <a:bodyPr wrap="square" rtlCol="0" anchor="ctr"/>
           <a:lstStyle/>
           <a:p>
-            <a:pPr algn="ctr" indent="0" marL="0">
+            <a:pPr marL="0" indent="0" algn="ctr">
               <a:buNone/>
             </a:pPr>
             <a:r>
@@ -4385,6 +4969,13 @@
             <a:prstDash val="solid"/>
           </a:ln>
         </p:spPr>
+        <p:txBody>
+          <a:bodyPr/>
+          <a:lstStyle/>
+          <a:p>
+            <a:endParaRPr lang="en-US"/>
+          </a:p>
+        </p:txBody>
       </p:sp>
       <p:sp>
         <p:nvSpPr>
@@ -4407,7 +4998,7 @@
           <a:bodyPr wrap="square" rtlCol="0" anchor="ctr"/>
           <a:lstStyle/>
           <a:p>
-            <a:pPr algn="ctr" indent="0" marL="0">
+            <a:pPr marL="0" indent="0" algn="ctr">
               <a:buNone/>
             </a:pPr>
             <a:r>
@@ -4444,6 +5035,13 @@
           </a:solidFill>
           <a:ln/>
         </p:spPr>
+        <p:txBody>
+          <a:bodyPr/>
+          <a:lstStyle/>
+          <a:p>
+            <a:endParaRPr lang="en-US"/>
+          </a:p>
+        </p:txBody>
       </p:sp>
       <p:sp>
         <p:nvSpPr>
@@ -4490,7 +5088,7 @@
             <a:endParaRPr lang="en-US" sz="1800" dirty="0"/>
           </a:p>
           <a:p>
-            <a:pPr indent="0" marL="0">
+            <a:pPr marL="0" indent="0">
               <a:lnSpc>
                 <a:spcPts val="2600"/>
               </a:lnSpc>
@@ -4513,7 +5111,7 @@
             <a:endParaRPr lang="en-US" sz="1800" dirty="0"/>
           </a:p>
           <a:p>
-            <a:pPr indent="0" marL="0">
+            <a:pPr marL="0" indent="0">
               <a:lnSpc>
                 <a:spcPts val="2600"/>
               </a:lnSpc>
@@ -4564,14 +5162,14 @@
       </p:grpSpPr>
       <p:pic>
         <p:nvPicPr>
-          <p:cNvPr id="2" name="Image 0" descr="C:\Users\a.abboud\Desktop\html unit\resources\week-03\scratch\assets\header.png">    </p:cNvPr>
+          <p:cNvPr id="2" name="Image 0" descr="C:\Users\a.abboud\Desktop\html unit\resources\week-03\scratch\assets\header.png"/>
           <p:cNvPicPr>
             <a:picLocks noChangeAspect="1"/>
           </p:cNvPicPr>
           <p:nvPr/>
         </p:nvPicPr>
         <p:blipFill>
-          <a:blip r:embed="rId1"/>
+          <a:blip r:embed="rId3"/>
           <a:stretch>
             <a:fillRect/>
           </a:stretch>
@@ -4588,14 +5186,14 @@
       </p:pic>
       <p:pic>
         <p:nvPicPr>
-          <p:cNvPr id="3" name="Image 1" descr="C:\Users\a.abboud\Desktop\html unit\resources\week-03\scratch\assets\footer.png">    </p:cNvPr>
+          <p:cNvPr id="3" name="Image 1" descr="C:\Users\a.abboud\Desktop\html unit\resources\week-03\scratch\assets\footer.png"/>
           <p:cNvPicPr>
             <a:picLocks noChangeAspect="1"/>
           </p:cNvPicPr>
           <p:nvPr/>
         </p:nvPicPr>
         <p:blipFill>
-          <a:blip r:embed="rId2"/>
+          <a:blip r:embed="rId4"/>
           <a:stretch>
             <a:fillRect/>
           </a:stretch>
@@ -4629,6 +5227,13 @@
           </a:solidFill>
           <a:ln/>
         </p:spPr>
+        <p:txBody>
+          <a:bodyPr/>
+          <a:lstStyle/>
+          <a:p>
+            <a:endParaRPr lang="en-US"/>
+          </a:p>
+        </p:txBody>
       </p:sp>
       <p:sp>
         <p:nvSpPr>
@@ -4651,7 +5256,7 @@
           <a:bodyPr wrap="square" rtlCol="0" anchor="ctr"/>
           <a:lstStyle/>
           <a:p>
-            <a:pPr algn="ctr" indent="0" marL="0">
+            <a:pPr marL="0" indent="0" algn="ctr">
               <a:buNone/>
             </a:pPr>
             <a:r>
@@ -4690,7 +5295,7 @@
           <a:bodyPr wrap="square" rtlCol="0" anchor="ctr"/>
           <a:lstStyle/>
           <a:p>
-            <a:pPr algn="ctr" indent="0" marL="0">
+            <a:pPr marL="0" indent="0" algn="ctr">
               <a:buNone/>
             </a:pPr>
             <a:r>
@@ -4730,6 +5335,13 @@
             <a:prstDash val="solid"/>
           </a:ln>
         </p:spPr>
+        <p:txBody>
+          <a:bodyPr/>
+          <a:lstStyle/>
+          <a:p>
+            <a:endParaRPr lang="en-US"/>
+          </a:p>
+        </p:txBody>
       </p:sp>
       <p:sp>
         <p:nvSpPr>
@@ -4752,7 +5364,7 @@
           <a:bodyPr wrap="square" rtlCol="0" anchor="ctr"/>
           <a:lstStyle/>
           <a:p>
-            <a:pPr algn="ctr" indent="0" marL="0">
+            <a:pPr marL="0" indent="0" algn="ctr">
               <a:buNone/>
             </a:pPr>
             <a:r>
@@ -4791,7 +5403,7 @@
           <a:bodyPr wrap="square" rtlCol="0" anchor="ctr"/>
           <a:lstStyle/>
           <a:p>
-            <a:pPr algn="ctr" indent="0" marL="0">
+            <a:pPr marL="0" indent="0" algn="ctr">
               <a:buNone/>
             </a:pPr>
             <a:r>
@@ -4828,6 +5440,13 @@
           </a:solidFill>
           <a:ln/>
         </p:spPr>
+        <p:txBody>
+          <a:bodyPr/>
+          <a:lstStyle/>
+          <a:p>
+            <a:endParaRPr lang="en-US"/>
+          </a:p>
+        </p:txBody>
       </p:sp>
       <p:sp>
         <p:nvSpPr>
@@ -4874,7 +5493,7 @@
             <a:endParaRPr lang="en-US" sz="1100" dirty="0"/>
           </a:p>
           <a:p>
-            <a:pPr indent="0" marL="0">
+            <a:pPr marL="0" indent="0">
               <a:lnSpc>
                 <a:spcPts val="1600"/>
               </a:lnSpc>
@@ -4897,7 +5516,7 @@
             <a:endParaRPr lang="en-US" sz="1100" dirty="0"/>
           </a:p>
           <a:p>
-            <a:pPr indent="0" marL="0">
+            <a:pPr marL="0" indent="0">
               <a:lnSpc>
                 <a:spcPts val="1600"/>
               </a:lnSpc>
@@ -4942,7 +5561,7 @@
           <a:bodyPr wrap="square" rtlCol="0" anchor="ctr"/>
           <a:lstStyle/>
           <a:p>
-            <a:pPr indent="0" marL="0">
+            <a:pPr marL="0" indent="0">
               <a:buNone/>
             </a:pPr>
             <a:r>
@@ -4979,6 +5598,13 @@
           </a:solidFill>
           <a:ln/>
         </p:spPr>
+        <p:txBody>
+          <a:bodyPr/>
+          <a:lstStyle/>
+          <a:p>
+            <a:endParaRPr lang="en-US"/>
+          </a:p>
+        </p:txBody>
       </p:sp>
       <p:sp>
         <p:nvSpPr>
@@ -5001,7 +5627,7 @@
           <a:bodyPr wrap="square" rtlCol="0" anchor="t"/>
           <a:lstStyle/>
           <a:p>
-            <a:pPr indent="0" marL="0">
+            <a:pPr marL="0" indent="0">
               <a:lnSpc>
                 <a:spcPts val="1365"/>
               </a:lnSpc>
@@ -5021,7 +5647,7 @@
             <a:endParaRPr lang="en-US" sz="1050" dirty="0"/>
           </a:p>
           <a:p>
-            <a:pPr indent="0" marL="0">
+            <a:pPr marL="0" indent="0">
               <a:lnSpc>
                 <a:spcPts val="1365"/>
               </a:lnSpc>
@@ -5041,7 +5667,7 @@
             <a:endParaRPr lang="en-US" sz="1050" dirty="0"/>
           </a:p>
           <a:p>
-            <a:pPr indent="0" marL="0">
+            <a:pPr marL="0" indent="0">
               <a:lnSpc>
                 <a:spcPts val="1365"/>
               </a:lnSpc>
@@ -5061,7 +5687,7 @@
             <a:endParaRPr lang="en-US" sz="1050" dirty="0"/>
           </a:p>
           <a:p>
-            <a:pPr indent="0" marL="0">
+            <a:pPr marL="0" indent="0">
               <a:lnSpc>
                 <a:spcPts val="1365"/>
               </a:lnSpc>
@@ -5081,7 +5707,7 @@
             <a:endParaRPr lang="en-US" sz="1050" dirty="0"/>
           </a:p>
           <a:p>
-            <a:pPr indent="0" marL="0">
+            <a:pPr marL="0" indent="0">
               <a:lnSpc>
                 <a:spcPts val="1365"/>
               </a:lnSpc>
@@ -5101,7 +5727,7 @@
             <a:endParaRPr lang="en-US" sz="1050" dirty="0"/>
           </a:p>
           <a:p>
-            <a:pPr indent="0" marL="0">
+            <a:pPr marL="0" indent="0">
               <a:lnSpc>
                 <a:spcPts val="1365"/>
               </a:lnSpc>
@@ -5121,7 +5747,7 @@
             <a:endParaRPr lang="en-US" sz="1050" dirty="0"/>
           </a:p>
           <a:p>
-            <a:pPr indent="0" marL="0">
+            <a:pPr marL="0" indent="0">
               <a:lnSpc>
                 <a:spcPts val="1365"/>
               </a:lnSpc>
@@ -5141,7 +5767,7 @@
             <a:endParaRPr lang="en-US" sz="1050" dirty="0"/>
           </a:p>
           <a:p>
-            <a:pPr indent="0" marL="0">
+            <a:pPr marL="0" indent="0">
               <a:lnSpc>
                 <a:spcPts val="1365"/>
               </a:lnSpc>
@@ -5189,14 +5815,14 @@
       </p:grpSpPr>
       <p:pic>
         <p:nvPicPr>
-          <p:cNvPr id="2" name="Image 0" descr="C:\Users\a.abboud\Desktop\html unit\resources\week-03\scratch\assets\header.png">    </p:cNvPr>
+          <p:cNvPr id="2" name="Image 0" descr="C:\Users\a.abboud\Desktop\html unit\resources\week-03\scratch\assets\header.png"/>
           <p:cNvPicPr>
             <a:picLocks noChangeAspect="1"/>
           </p:cNvPicPr>
           <p:nvPr/>
         </p:nvPicPr>
         <p:blipFill>
-          <a:blip r:embed="rId1"/>
+          <a:blip r:embed="rId3"/>
           <a:stretch>
             <a:fillRect/>
           </a:stretch>
@@ -5213,14 +5839,14 @@
       </p:pic>
       <p:pic>
         <p:nvPicPr>
-          <p:cNvPr id="3" name="Image 1" descr="C:\Users\a.abboud\Desktop\html unit\resources\week-03\scratch\assets\footer.png">    </p:cNvPr>
+          <p:cNvPr id="3" name="Image 1" descr="C:\Users\a.abboud\Desktop\html unit\resources\week-03\scratch\assets\footer.png"/>
           <p:cNvPicPr>
             <a:picLocks noChangeAspect="1"/>
           </p:cNvPicPr>
           <p:nvPr/>
         </p:nvPicPr>
         <p:blipFill>
-          <a:blip r:embed="rId2"/>
+          <a:blip r:embed="rId4"/>
           <a:stretch>
             <a:fillRect/>
           </a:stretch>
@@ -5254,6 +5880,13 @@
           </a:solidFill>
           <a:ln/>
         </p:spPr>
+        <p:txBody>
+          <a:bodyPr/>
+          <a:lstStyle/>
+          <a:p>
+            <a:endParaRPr lang="en-US"/>
+          </a:p>
+        </p:txBody>
       </p:sp>
       <p:sp>
         <p:nvSpPr>
@@ -5276,7 +5909,7 @@
           <a:bodyPr wrap="square" rtlCol="0" anchor="ctr"/>
           <a:lstStyle/>
           <a:p>
-            <a:pPr algn="ctr" indent="0" marL="0">
+            <a:pPr marL="0" indent="0" algn="ctr">
               <a:buNone/>
             </a:pPr>
             <a:r>
@@ -5315,7 +5948,7 @@
           <a:bodyPr wrap="square" rtlCol="0" anchor="ctr"/>
           <a:lstStyle/>
           <a:p>
-            <a:pPr algn="ctr" indent="0" marL="0">
+            <a:pPr marL="0" indent="0" algn="ctr">
               <a:buNone/>
             </a:pPr>
             <a:r>
@@ -5355,6 +5988,13 @@
             <a:prstDash val="solid"/>
           </a:ln>
         </p:spPr>
+        <p:txBody>
+          <a:bodyPr/>
+          <a:lstStyle/>
+          <a:p>
+            <a:endParaRPr lang="en-US"/>
+          </a:p>
+        </p:txBody>
       </p:sp>
       <p:sp>
         <p:nvSpPr>
@@ -5377,7 +6017,7 @@
           <a:bodyPr wrap="square" rtlCol="0" anchor="ctr"/>
           <a:lstStyle/>
           <a:p>
-            <a:pPr algn="ctr" indent="0" marL="0">
+            <a:pPr marL="0" indent="0" algn="ctr">
               <a:buNone/>
             </a:pPr>
             <a:r>
@@ -5416,7 +6056,7 @@
           <a:bodyPr wrap="square" rtlCol="0" anchor="ctr"/>
           <a:lstStyle/>
           <a:p>
-            <a:pPr algn="ctr" indent="0" marL="0">
+            <a:pPr marL="0" indent="0" algn="ctr">
               <a:buNone/>
             </a:pPr>
             <a:r>
@@ -5453,6 +6093,13 @@
           </a:solidFill>
           <a:ln/>
         </p:spPr>
+        <p:txBody>
+          <a:bodyPr/>
+          <a:lstStyle/>
+          <a:p>
+            <a:endParaRPr lang="en-US"/>
+          </a:p>
+        </p:txBody>
       </p:sp>
       <p:sp>
         <p:nvSpPr>
@@ -5463,7 +6110,7 @@
         <p:spPr>
           <a:xfrm>
             <a:off x="2880360" y="1280160"/>
-            <a:ext cx="5760720" cy="2971800"/>
+            <a:ext cx="5760720" cy="1108583"/>
           </a:xfrm>
           <a:prstGeom prst="rect">
             <a:avLst/>
@@ -5477,39 +6124,16 @@
           <a:p>
             <a:pPr marL="342900" indent="-342900">
               <a:lnSpc>
-                <a:spcPts val="2600"/>
-              </a:lnSpc>
-              <a:spcAft>
-                <a:spcPts val="1000"/>
-              </a:spcAft>
-              <a:buSzPct val="100000"/>
-              <a:buChar char="●"/>
-            </a:pPr>
-            <a:r>
-              <a:rPr lang="en-US" sz="1800" b="1" dirty="0">
-                <a:solidFill>
-                  <a:srgbClr val="1A1A1A"/>
-                </a:solidFill>
-                <a:latin typeface="Arial" pitchFamily="34" charset="0"/>
-                <a:ea typeface="Arial" pitchFamily="34" charset="-122"/>
-                <a:cs typeface="Arial" pitchFamily="34" charset="-120"/>
-              </a:rPr>
-              <a:t>We Do: 3 Reads of the Example</a:t>
-            </a:r>
-            <a:endParaRPr lang="en-US" sz="1800" dirty="0"/>
-          </a:p>
-          <a:p>
-            <a:pPr indent="0" marL="0">
-              <a:lnSpc>
-                <a:spcPts val="2600"/>
+                <a:spcPts val="1800"/>
               </a:lnSpc>
               <a:spcAft>
                 <a:spcPts val="800"/>
               </a:spcAft>
-              <a:buNone/>
-            </a:pPr>
-            <a:r>
-              <a:rPr lang="en-US" sz="1800" dirty="0">
+              <a:buSzPct val="100000"/>
+              <a:buChar char="●"/>
+            </a:pPr>
+            <a:r>
+              <a:rPr lang="en-US" sz="1300" b="1" dirty="0">
                 <a:solidFill>
                   <a:srgbClr val="1A1A1A"/>
                 </a:solidFill>
@@ -5517,55 +6141,242 @@
                 <a:ea typeface="Arial" pitchFamily="34" charset="-122"/>
                 <a:cs typeface="Arial" pitchFamily="34" charset="-120"/>
               </a:rPr>
-              <a:t>Read 1 - what is this page about? Read 2 - which headings/paragraphs carry which ideas?</a:t>
-            </a:r>
-            <a:endParaRPr lang="en-US" sz="1800" dirty="0"/>
-          </a:p>
-          <a:p>
-            <a:pPr indent="0" marL="0">
+              <a:t>We Do: 3 Reads of the Example</a:t>
+            </a:r>
+            <a:endParaRPr lang="en-US" sz="1300" dirty="0"/>
+          </a:p>
+          <a:p>
+            <a:pPr marL="0" indent="0">
               <a:lnSpc>
-                <a:spcPts val="2600"/>
+                <a:spcPts val="1800"/>
               </a:lnSpc>
+              <a:spcAft>
+                <a:spcPts val="600"/>
+              </a:spcAft>
+              <a:buNone/>
+            </a:pPr>
+            <a:r>
+              <a:rPr lang="en-US" sz="1300" dirty="0">
+                <a:solidFill>
+                  <a:srgbClr val="1A1A1A"/>
+                </a:solidFill>
+                <a:latin typeface="Arial" pitchFamily="34" charset="0"/>
+                <a:ea typeface="Arial" pitchFamily="34" charset="-122"/>
+                <a:cs typeface="Arial" pitchFamily="34" charset="-120"/>
+              </a:rPr>
+              <a:t>Apply the 3 Reads to the page on the right: what's it about, which ideas go where, and why is it easier to read than the warm-up's wall of text?</a:t>
+            </a:r>
+            <a:endParaRPr lang="en-US" sz="1300" dirty="0"/>
+          </a:p>
+        </p:txBody>
+      </p:sp>
+      <p:sp>
+        <p:nvSpPr>
+          <p:cNvPr id="12" name="Text 8"/>
+          <p:cNvSpPr/>
+          <p:nvPr/>
+        </p:nvSpPr>
+        <p:spPr>
+          <a:xfrm>
+            <a:off x="2880360" y="2461895"/>
+            <a:ext cx="5760720" cy="237744"/>
+          </a:xfrm>
+          <a:prstGeom prst="rect">
+            <a:avLst/>
+          </a:prstGeom>
+          <a:noFill/>
+          <a:ln/>
+        </p:spPr>
+        <p:txBody>
+          <a:bodyPr wrap="square" rtlCol="0" anchor="ctr"/>
+          <a:lstStyle/>
+          <a:p>
+            <a:pPr marL="0" indent="0">
+              <a:buNone/>
+            </a:pPr>
+            <a:r>
+              <a:rPr lang="en-US" sz="1100" i="1" dirty="0">
+                <a:solidFill>
+                  <a:srgbClr val="6B7785"/>
+                </a:solidFill>
+                <a:latin typeface="Arial" pitchFamily="34" charset="0"/>
+                <a:ea typeface="Arial" pitchFamily="34" charset="-122"/>
+                <a:cs typeface="Arial" pitchFamily="34" charset="-120"/>
+              </a:rPr>
+              <a:t>The example page, rendered</a:t>
+            </a:r>
+            <a:endParaRPr lang="en-US" sz="1100" dirty="0"/>
+          </a:p>
+        </p:txBody>
+      </p:sp>
+      <p:sp>
+        <p:nvSpPr>
+          <p:cNvPr id="13" name="Shape 9"/>
+          <p:cNvSpPr/>
+          <p:nvPr/>
+        </p:nvSpPr>
+        <p:spPr>
+          <a:xfrm>
+            <a:off x="2880360" y="2754503"/>
+            <a:ext cx="5760720" cy="1680337"/>
+          </a:xfrm>
+          <a:prstGeom prst="rect">
+            <a:avLst/>
+          </a:prstGeom>
+          <a:solidFill>
+            <a:srgbClr val="FFFFFF"/>
+          </a:solidFill>
+          <a:ln w="12700">
+            <a:solidFill>
+              <a:srgbClr val="D8E4EC"/>
+            </a:solidFill>
+            <a:prstDash val="solid"/>
+          </a:ln>
+        </p:spPr>
+        <p:txBody>
+          <a:bodyPr/>
+          <a:lstStyle/>
+          <a:p>
+            <a:endParaRPr lang="en-US"/>
+          </a:p>
+        </p:txBody>
+      </p:sp>
+      <p:sp>
+        <p:nvSpPr>
+          <p:cNvPr id="14" name="Text 10"/>
+          <p:cNvSpPr/>
+          <p:nvPr/>
+        </p:nvSpPr>
+        <p:spPr>
+          <a:xfrm>
+            <a:off x="3008376" y="2882519"/>
+            <a:ext cx="5504688" cy="1424305"/>
+          </a:xfrm>
+          <a:prstGeom prst="rect">
+            <a:avLst/>
+          </a:prstGeom>
+          <a:noFill/>
+          <a:ln/>
+        </p:spPr>
+        <p:txBody>
+          <a:bodyPr wrap="square" rtlCol="0" anchor="t"/>
+          <a:lstStyle/>
+          <a:p>
+            <a:pPr marL="0" indent="0">
+              <a:spcAft>
+                <a:spcPts val="500"/>
+              </a:spcAft>
+              <a:buNone/>
+            </a:pPr>
+            <a:r>
+              <a:rPr lang="en-US" sz="1500" b="1" dirty="0">
+                <a:solidFill>
+                  <a:srgbClr val="1A1A1A"/>
+                </a:solidFill>
+                <a:latin typeface="Calibri" pitchFamily="34" charset="0"/>
+                <a:ea typeface="Calibri" pitchFamily="34" charset="-122"/>
+                <a:cs typeface="Calibri" pitchFamily="34" charset="-120"/>
+              </a:rPr>
+              <a:t>My Website</a:t>
+            </a:r>
+            <a:endParaRPr lang="en-US" sz="1500" dirty="0"/>
+          </a:p>
+          <a:p>
+            <a:pPr marL="0" indent="0">
               <a:spcAft>
                 <a:spcPts val="800"/>
               </a:spcAft>
               <a:buNone/>
             </a:pPr>
             <a:r>
-              <a:rPr lang="en-US" sz="1800" dirty="0">
+              <a:rPr lang="en-US" sz="950" dirty="0">
                 <a:solidFill>
                   <a:srgbClr val="1A1A1A"/>
                 </a:solidFill>
-                <a:latin typeface="Arial" pitchFamily="34" charset="0"/>
-                <a:ea typeface="Arial" pitchFamily="34" charset="-122"/>
-                <a:cs typeface="Arial" pitchFamily="34" charset="-120"/>
-              </a:rPr>
-              <a:t>Read 3 - why does this structure make it easier to read than the warm-up's wall of text?</a:t>
-            </a:r>
-            <a:endParaRPr lang="en-US" sz="1800" dirty="0"/>
-          </a:p>
-          <a:p>
-            <a:pPr indent="0" marL="0">
-              <a:lnSpc>
-                <a:spcPts val="2600"/>
-              </a:lnSpc>
+                <a:latin typeface="Calibri" pitchFamily="34" charset="0"/>
+                <a:ea typeface="Calibri" pitchFamily="34" charset="-122"/>
+                <a:cs typeface="Calibri" pitchFamily="34" charset="-120"/>
+              </a:rPr>
+              <a:t>Welcome to my personal site.</a:t>
+            </a:r>
+            <a:endParaRPr lang="en-US" sz="1500" dirty="0"/>
+          </a:p>
+          <a:p>
+            <a:pPr marL="0" indent="0">
+              <a:spcAft>
+                <a:spcPts val="300"/>
+              </a:spcAft>
+              <a:buNone/>
+            </a:pPr>
+            <a:r>
+              <a:rPr lang="en-US" sz="1100" b="1" dirty="0">
+                <a:solidFill>
+                  <a:srgbClr val="1A1A1A"/>
+                </a:solidFill>
+                <a:latin typeface="Calibri" pitchFamily="34" charset="0"/>
+                <a:ea typeface="Calibri" pitchFamily="34" charset="-122"/>
+                <a:cs typeface="Calibri" pitchFamily="34" charset="-120"/>
+              </a:rPr>
+              <a:t>About Me</a:t>
+            </a:r>
+            <a:endParaRPr lang="en-US" sz="1500" dirty="0"/>
+          </a:p>
+          <a:p>
+            <a:pPr marL="0" indent="0">
               <a:spcAft>
                 <a:spcPts val="800"/>
               </a:spcAft>
               <a:buNone/>
             </a:pPr>
             <a:r>
-              <a:rPr lang="en-US" sz="1800" dirty="0">
+              <a:rPr lang="en-US" sz="950" dirty="0">
                 <a:solidFill>
                   <a:srgbClr val="1A1A1A"/>
                 </a:solidFill>
-                <a:latin typeface="Arial" pitchFamily="34" charset="0"/>
-                <a:ea typeface="Arial" pitchFamily="34" charset="-122"/>
-                <a:cs typeface="Arial" pitchFamily="34" charset="-120"/>
-              </a:rPr>
-              <a:t>Guided notes: record the hierarchy rules, plus one correct vs. incorrect example.</a:t>
-            </a:r>
-            <a:endParaRPr lang="en-US" sz="1800" dirty="0"/>
+                <a:latin typeface="Calibri" pitchFamily="34" charset="0"/>
+                <a:ea typeface="Calibri" pitchFamily="34" charset="-122"/>
+                <a:cs typeface="Calibri" pitchFamily="34" charset="-120"/>
+              </a:rPr>
+              <a:t>A short paragraph about who I am.</a:t>
+            </a:r>
+            <a:endParaRPr lang="en-US" sz="1500" dirty="0"/>
+          </a:p>
+          <a:p>
+            <a:pPr marL="0" indent="0">
+              <a:spcAft>
+                <a:spcPts val="300"/>
+              </a:spcAft>
+              <a:buNone/>
+            </a:pPr>
+            <a:r>
+              <a:rPr lang="en-US" sz="1100" b="1" dirty="0">
+                <a:solidFill>
+                  <a:srgbClr val="1A1A1A"/>
+                </a:solidFill>
+                <a:latin typeface="Calibri" pitchFamily="34" charset="0"/>
+                <a:ea typeface="Calibri" pitchFamily="34" charset="-122"/>
+                <a:cs typeface="Calibri" pitchFamily="34" charset="-120"/>
+              </a:rPr>
+              <a:t>My Hobbies</a:t>
+            </a:r>
+            <a:endParaRPr lang="en-US" sz="1500" dirty="0"/>
+          </a:p>
+          <a:p>
+            <a:pPr marL="0" indent="0">
+              <a:buNone/>
+            </a:pPr>
+            <a:r>
+              <a:rPr lang="en-US" sz="950" dirty="0">
+                <a:solidFill>
+                  <a:srgbClr val="1A1A1A"/>
+                </a:solidFill>
+                <a:latin typeface="Calibri" pitchFamily="34" charset="0"/>
+                <a:ea typeface="Calibri" pitchFamily="34" charset="-122"/>
+                <a:cs typeface="Calibri" pitchFamily="34" charset="-120"/>
+              </a:rPr>
+              <a:t>A short paragraph about what I enjoy doing.</a:t>
+            </a:r>
+            <a:endParaRPr lang="en-US" sz="1500" dirty="0"/>
           </a:p>
         </p:txBody>
       </p:sp>
@@ -5579,10 +6390,16 @@
 
 <file path=ppt/slides/slide9.xml><?xml version="1.0" encoding="utf-8"?>
 <p:sld xmlns:a="http://schemas.openxmlformats.org/drawingml/2006/main" xmlns:r="http://schemas.openxmlformats.org/officeDocument/2006/relationships" xmlns:p="http://schemas.openxmlformats.org/presentationml/2006/main">
-  <p:cSld name="Slide 9">
+  <p:cSld>
     <p:spTree>
       <p:nvGrpSpPr>
-        <p:cNvPr id="1" name=""/>
+        <p:cNvPr id="1" name="">
+          <a:extLst>
+            <a:ext uri="{FF2B5EF4-FFF2-40B4-BE49-F238E27FC236}">
+              <a16:creationId xmlns:a16="http://schemas.microsoft.com/office/drawing/2014/main" id="{0A1D8D53-0D62-EAD6-BEDC-F8A8D206D5ED}"/>
+            </a:ext>
+          </a:extLst>
+        </p:cNvPr>
         <p:cNvGrpSpPr/>
         <p:nvPr/>
       </p:nvGrpSpPr>
@@ -5596,14 +6413,20 @@
       </p:grpSpPr>
       <p:pic>
         <p:nvPicPr>
-          <p:cNvPr id="2" name="Image 0" descr="C:\Users\a.abboud\Desktop\html unit\resources\week-03\scratch\assets\header.png">    </p:cNvPr>
+          <p:cNvPr id="2" name="Image 0" descr="C:\Users\a.abboud\Desktop\html unit\resources\week-03\scratch\assets\header.png">
+            <a:extLst>
+              <a:ext uri="{FF2B5EF4-FFF2-40B4-BE49-F238E27FC236}">
+                <a16:creationId xmlns:a16="http://schemas.microsoft.com/office/drawing/2014/main" id="{5E25D646-8815-84FA-1786-CEE5138F59BA}"/>
+              </a:ext>
+            </a:extLst>
+          </p:cNvPr>
           <p:cNvPicPr>
             <a:picLocks noChangeAspect="1"/>
           </p:cNvPicPr>
           <p:nvPr/>
         </p:nvPicPr>
         <p:blipFill>
-          <a:blip r:embed="rId1"/>
+          <a:blip r:embed="rId3"/>
           <a:stretch>
             <a:fillRect/>
           </a:stretch>
@@ -5620,14 +6443,20 @@
       </p:pic>
       <p:pic>
         <p:nvPicPr>
-          <p:cNvPr id="3" name="Image 1" descr="C:\Users\a.abboud\Desktop\html unit\resources\week-03\scratch\assets\footer.png">    </p:cNvPr>
+          <p:cNvPr id="3" name="Image 1" descr="C:\Users\a.abboud\Desktop\html unit\resources\week-03\scratch\assets\footer.png">
+            <a:extLst>
+              <a:ext uri="{FF2B5EF4-FFF2-40B4-BE49-F238E27FC236}">
+                <a16:creationId xmlns:a16="http://schemas.microsoft.com/office/drawing/2014/main" id="{46609FE3-802D-CAE9-E9DB-0DD3D372956A}"/>
+              </a:ext>
+            </a:extLst>
+          </p:cNvPr>
           <p:cNvPicPr>
             <a:picLocks noChangeAspect="1"/>
           </p:cNvPicPr>
           <p:nvPr/>
         </p:nvPicPr>
         <p:blipFill>
-          <a:blip r:embed="rId2"/>
+          <a:blip r:embed="rId4"/>
           <a:stretch>
             <a:fillRect/>
           </a:stretch>
@@ -5644,7 +6473,13 @@
       </p:pic>
       <p:sp>
         <p:nvSpPr>
-          <p:cNvPr id="4" name="Shape 0"/>
+          <p:cNvPr id="4" name="Shape 0">
+            <a:extLst>
+              <a:ext uri="{FF2B5EF4-FFF2-40B4-BE49-F238E27FC236}">
+                <a16:creationId xmlns:a16="http://schemas.microsoft.com/office/drawing/2014/main" id="{1DDFBB92-E643-42E5-8D85-A7A5F76E0B43}"/>
+              </a:ext>
+            </a:extLst>
+          </p:cNvPr>
           <p:cNvSpPr/>
           <p:nvPr/>
         </p:nvSpPr>
@@ -5661,10 +6496,23 @@
           </a:solidFill>
           <a:ln/>
         </p:spPr>
-      </p:sp>
-      <p:sp>
-        <p:nvSpPr>
-          <p:cNvPr id="5" name="Text 1"/>
+        <p:txBody>
+          <a:bodyPr/>
+          <a:lstStyle/>
+          <a:p>
+            <a:endParaRPr lang="en-US"/>
+          </a:p>
+        </p:txBody>
+      </p:sp>
+      <p:sp>
+        <p:nvSpPr>
+          <p:cNvPr id="5" name="Text 1">
+            <a:extLst>
+              <a:ext uri="{FF2B5EF4-FFF2-40B4-BE49-F238E27FC236}">
+                <a16:creationId xmlns:a16="http://schemas.microsoft.com/office/drawing/2014/main" id="{4296C8A2-7376-CAC3-AB1B-F3E4AC29DD51}"/>
+              </a:ext>
+            </a:extLst>
+          </p:cNvPr>
           <p:cNvSpPr/>
           <p:nvPr/>
         </p:nvSpPr>
@@ -5683,7 +6531,7 @@
           <a:bodyPr wrap="square" rtlCol="0" anchor="ctr"/>
           <a:lstStyle/>
           <a:p>
-            <a:pPr algn="ctr" indent="0" marL="0">
+            <a:pPr marL="0" indent="0" algn="ctr">
               <a:buNone/>
             </a:pPr>
             <a:r>
@@ -5703,7 +6551,13 @@
       </p:sp>
       <p:sp>
         <p:nvSpPr>
-          <p:cNvPr id="6" name="Text 2"/>
+          <p:cNvPr id="6" name="Text 2">
+            <a:extLst>
+              <a:ext uri="{FF2B5EF4-FFF2-40B4-BE49-F238E27FC236}">
+                <a16:creationId xmlns:a16="http://schemas.microsoft.com/office/drawing/2014/main" id="{0FAB03A2-22F4-5F2D-B872-A4D5E05F3258}"/>
+              </a:ext>
+            </a:extLst>
+          </p:cNvPr>
           <p:cNvSpPr/>
           <p:nvPr/>
         </p:nvSpPr>
@@ -5722,7 +6576,7 @@
           <a:bodyPr wrap="square" rtlCol="0" anchor="ctr"/>
           <a:lstStyle/>
           <a:p>
-            <a:pPr algn="ctr" indent="0" marL="0">
+            <a:pPr marL="0" indent="0" algn="ctr">
               <a:buNone/>
             </a:pPr>
             <a:r>
@@ -5742,7 +6596,13 @@
       </p:sp>
       <p:sp>
         <p:nvSpPr>
-          <p:cNvPr id="7" name="Shape 3"/>
+          <p:cNvPr id="7" name="Shape 3">
+            <a:extLst>
+              <a:ext uri="{FF2B5EF4-FFF2-40B4-BE49-F238E27FC236}">
+                <a16:creationId xmlns:a16="http://schemas.microsoft.com/office/drawing/2014/main" id="{1CBD137F-40B7-8698-464E-EC5A88C990B5}"/>
+              </a:ext>
+            </a:extLst>
+          </p:cNvPr>
           <p:cNvSpPr/>
           <p:nvPr/>
         </p:nvSpPr>
@@ -5762,10 +6622,23 @@
             <a:prstDash val="solid"/>
           </a:ln>
         </p:spPr>
-      </p:sp>
-      <p:sp>
-        <p:nvSpPr>
-          <p:cNvPr id="8" name="Text 4"/>
+        <p:txBody>
+          <a:bodyPr/>
+          <a:lstStyle/>
+          <a:p>
+            <a:endParaRPr lang="en-US"/>
+          </a:p>
+        </p:txBody>
+      </p:sp>
+      <p:sp>
+        <p:nvSpPr>
+          <p:cNvPr id="8" name="Text 4">
+            <a:extLst>
+              <a:ext uri="{FF2B5EF4-FFF2-40B4-BE49-F238E27FC236}">
+                <a16:creationId xmlns:a16="http://schemas.microsoft.com/office/drawing/2014/main" id="{86911679-F650-C436-430E-DC3B90CF6471}"/>
+              </a:ext>
+            </a:extLst>
+          </p:cNvPr>
           <p:cNvSpPr/>
           <p:nvPr/>
         </p:nvSpPr>
@@ -5784,7 +6657,7 @@
           <a:bodyPr wrap="square" rtlCol="0" anchor="ctr"/>
           <a:lstStyle/>
           <a:p>
-            <a:pPr algn="ctr" indent="0" marL="0">
+            <a:pPr marL="0" indent="0" algn="ctr">
               <a:buNone/>
             </a:pPr>
             <a:r>
@@ -5804,7 +6677,13 @@
       </p:sp>
       <p:sp>
         <p:nvSpPr>
-          <p:cNvPr id="9" name="Text 5"/>
+          <p:cNvPr id="9" name="Text 5">
+            <a:extLst>
+              <a:ext uri="{FF2B5EF4-FFF2-40B4-BE49-F238E27FC236}">
+                <a16:creationId xmlns:a16="http://schemas.microsoft.com/office/drawing/2014/main" id="{7E45740A-A22F-0EEB-8BC7-8F40E321AAFD}"/>
+              </a:ext>
+            </a:extLst>
+          </p:cNvPr>
           <p:cNvSpPr/>
           <p:nvPr/>
         </p:nvSpPr>
@@ -5823,7 +6702,7 @@
           <a:bodyPr wrap="square" rtlCol="0" anchor="ctr"/>
           <a:lstStyle/>
           <a:p>
-            <a:pPr algn="ctr" indent="0" marL="0">
+            <a:pPr marL="0" indent="0" algn="ctr">
               <a:buNone/>
             </a:pPr>
             <a:r>
@@ -5835,7 +6714,7 @@
                 <a:ea typeface="Arial" pitchFamily="34" charset="-122"/>
                 <a:cs typeface="Arial" pitchFamily="34" charset="-120"/>
               </a:rPr>
-              <a:t>3 / 3</a:t>
+              <a:t>2 / 3</a:t>
             </a:r>
             <a:endParaRPr lang="en-US" sz="1100" dirty="0"/>
           </a:p>
@@ -5843,7 +6722,13 @@
       </p:sp>
       <p:sp>
         <p:nvSpPr>
-          <p:cNvPr id="10" name="Shape 6"/>
+          <p:cNvPr id="10" name="Shape 6">
+            <a:extLst>
+              <a:ext uri="{FF2B5EF4-FFF2-40B4-BE49-F238E27FC236}">
+                <a16:creationId xmlns:a16="http://schemas.microsoft.com/office/drawing/2014/main" id="{968CCE57-DF22-84E8-DA89-BAB4DA0A324F}"/>
+              </a:ext>
+            </a:extLst>
+          </p:cNvPr>
           <p:cNvSpPr/>
           <p:nvPr/>
         </p:nvSpPr>
@@ -5860,17 +6745,30 @@
           </a:solidFill>
           <a:ln/>
         </p:spPr>
-      </p:sp>
-      <p:sp>
-        <p:nvSpPr>
-          <p:cNvPr id="11" name="Text 7"/>
+        <p:txBody>
+          <a:bodyPr/>
+          <a:lstStyle/>
+          <a:p>
+            <a:endParaRPr lang="en-US"/>
+          </a:p>
+        </p:txBody>
+      </p:sp>
+      <p:sp>
+        <p:nvSpPr>
+          <p:cNvPr id="11" name="Text 7">
+            <a:extLst>
+              <a:ext uri="{FF2B5EF4-FFF2-40B4-BE49-F238E27FC236}">
+                <a16:creationId xmlns:a16="http://schemas.microsoft.com/office/drawing/2014/main" id="{C25C5444-5464-4BA2-FF91-BC44F2C56FFA}"/>
+              </a:ext>
+            </a:extLst>
+          </p:cNvPr>
           <p:cNvSpPr/>
           <p:nvPr/>
         </p:nvSpPr>
         <p:spPr>
           <a:xfrm>
             <a:off x="2880360" y="1280160"/>
-            <a:ext cx="3163824" cy="2971800"/>
+            <a:ext cx="5760720" cy="1108583"/>
           </a:xfrm>
           <a:prstGeom prst="rect">
             <a:avLst/>
@@ -5884,7 +6782,7 @@
           <a:p>
             <a:pPr marL="342900" indent="-342900">
               <a:lnSpc>
-                <a:spcPts val="2000"/>
+                <a:spcPts val="1800"/>
               </a:lnSpc>
               <a:spcAft>
                 <a:spcPts val="800"/>
@@ -5893,7 +6791,7 @@
               <a:buChar char="●"/>
             </a:pPr>
             <a:r>
-              <a:rPr lang="en-US" sz="1500" b="1" dirty="0">
+              <a:rPr lang="en-US" sz="1300" b="1" dirty="0">
                 <a:solidFill>
                   <a:srgbClr val="1A1A1A"/>
                 </a:solidFill>
@@ -5901,14 +6799,14 @@
                 <a:ea typeface="Arial" pitchFamily="34" charset="-122"/>
                 <a:cs typeface="Arial" pitchFamily="34" charset="-120"/>
               </a:rPr>
-              <a:t>You Do: Code the Healthy Food Page</a:t>
-            </a:r>
-            <a:endParaRPr lang="en-US" sz="1500" dirty="0"/>
-          </a:p>
-          <a:p>
-            <a:pPr indent="0" marL="0">
+              <a:t>We Do: 3 Reads of the Example</a:t>
+            </a:r>
+            <a:endParaRPr lang="en-US" sz="1300" dirty="0"/>
+          </a:p>
+          <a:p>
+            <a:pPr marL="0" indent="0">
               <a:lnSpc>
-                <a:spcPts val="2000"/>
+                <a:spcPts val="1800"/>
               </a:lnSpc>
               <a:spcAft>
                 <a:spcPts val="600"/>
@@ -5916,7 +6814,7 @@
               <a:buNone/>
             </a:pPr>
             <a:r>
-              <a:rPr lang="en-US" sz="1500" dirty="0">
+              <a:rPr lang="en-US" sz="1300" dirty="0">
                 <a:solidFill>
                   <a:srgbClr val="1A1A1A"/>
                 </a:solidFill>
@@ -5924,22 +6822,28 @@
                 <a:ea typeface="Arial" pitchFamily="34" charset="-122"/>
                 <a:cs typeface="Arial" pitchFamily="34" charset="-120"/>
               </a:rPr>
-              <a:t>You're given the finished webpage - write the HTML code that would build it, using the right heading and paragraph tags.</a:t>
-            </a:r>
-            <a:endParaRPr lang="en-US" sz="1500" dirty="0"/>
-          </a:p>
-        </p:txBody>
-      </p:sp>
-      <p:sp>
-        <p:nvSpPr>
-          <p:cNvPr id="12" name="Text 8"/>
-          <p:cNvSpPr/>
-          <p:nvPr/>
-        </p:nvSpPr>
-        <p:spPr>
-          <a:xfrm>
-            <a:off x="6236208" y="1280160"/>
-            <a:ext cx="2404872" cy="384048"/>
+              <a:t>Apply the 3 Reads to the page on the right: what's it about, which ideas go where, and why is it easier to read than the warm-up's wall of text?</a:t>
+            </a:r>
+            <a:endParaRPr lang="en-US" sz="1300" dirty="0"/>
+          </a:p>
+        </p:txBody>
+      </p:sp>
+      <p:sp>
+        <p:nvSpPr>
+          <p:cNvPr id="12" name="Text 8">
+            <a:extLst>
+              <a:ext uri="{FF2B5EF4-FFF2-40B4-BE49-F238E27FC236}">
+                <a16:creationId xmlns:a16="http://schemas.microsoft.com/office/drawing/2014/main" id="{0C92775E-A600-F195-49F8-BA57E130AEBC}"/>
+              </a:ext>
+            </a:extLst>
+          </p:cNvPr>
+          <p:cNvSpPr/>
+          <p:nvPr/>
+        </p:nvSpPr>
+        <p:spPr>
+          <a:xfrm>
+            <a:off x="2880360" y="2461895"/>
+            <a:ext cx="5760720" cy="237744"/>
           </a:xfrm>
           <a:prstGeom prst="rect">
             <a:avLst/>
@@ -5948,14 +6852,14 @@
           <a:ln/>
         </p:spPr>
         <p:txBody>
-          <a:bodyPr wrap="square" rtlCol="0" anchor="t"/>
-          <a:lstStyle/>
-          <a:p>
-            <a:pPr indent="0" marL="0">
-              <a:buNone/>
-            </a:pPr>
-            <a:r>
-              <a:rPr lang="en-US" sz="1050" i="1" dirty="0">
+          <a:bodyPr wrap="square" rtlCol="0" anchor="ctr"/>
+          <a:lstStyle/>
+          <a:p>
+            <a:pPr marL="0" indent="0">
+              <a:buNone/>
+            </a:pPr>
+            <a:r>
+              <a:rPr lang="en-US" sz="1100" i="1" dirty="0">
                 <a:solidFill>
                   <a:srgbClr val="6B7785"/>
                 </a:solidFill>
@@ -5963,22 +6867,28 @@
                 <a:ea typeface="Arial" pitchFamily="34" charset="-122"/>
                 <a:cs typeface="Arial" pitchFamily="34" charset="-120"/>
               </a:rPr>
-              <a:t>Activity: Code This Page - Healthy Food</a:t>
-            </a:r>
-            <a:endParaRPr lang="en-US" sz="1050" dirty="0"/>
-          </a:p>
-        </p:txBody>
-      </p:sp>
-      <p:sp>
-        <p:nvSpPr>
-          <p:cNvPr id="13" name="Shape 9"/>
-          <p:cNvSpPr/>
-          <p:nvPr/>
-        </p:nvSpPr>
-        <p:spPr>
-          <a:xfrm>
-            <a:off x="6236208" y="1700784"/>
-            <a:ext cx="2404872" cy="2551176"/>
+              <a:t>The example page, rendered</a:t>
+            </a:r>
+            <a:endParaRPr lang="en-US" sz="1100" dirty="0"/>
+          </a:p>
+        </p:txBody>
+      </p:sp>
+      <p:sp>
+        <p:nvSpPr>
+          <p:cNvPr id="13" name="Shape 9">
+            <a:extLst>
+              <a:ext uri="{FF2B5EF4-FFF2-40B4-BE49-F238E27FC236}">
+                <a16:creationId xmlns:a16="http://schemas.microsoft.com/office/drawing/2014/main" id="{BBAB3F49-E91B-86A6-7DEE-43F7A89B9E0D}"/>
+              </a:ext>
+            </a:extLst>
+          </p:cNvPr>
+          <p:cNvSpPr/>
+          <p:nvPr/>
+        </p:nvSpPr>
+        <p:spPr>
+          <a:xfrm>
+            <a:off x="2880360" y="2754503"/>
+            <a:ext cx="5760720" cy="1680337"/>
           </a:xfrm>
           <a:prstGeom prst="rect">
             <a:avLst/>
@@ -5993,32 +6903,165 @@
             <a:prstDash val="solid"/>
           </a:ln>
         </p:spPr>
-      </p:sp>
-      <p:pic>
-        <p:nvPicPr>
-          <p:cNvPr id="14" name="Image 2" descr="C:\Users\a.abboud\Desktop\html unit\resources\week-03\scratch\assets\W3L1 - Code This Page - Healthy Food_cropped.png">    </p:cNvPr>
-          <p:cNvPicPr>
-            <a:picLocks noChangeAspect="1"/>
-          </p:cNvPicPr>
-          <p:nvPr/>
-        </p:nvPicPr>
-        <p:blipFill>
-          <a:blip r:embed="rId3"/>
-          <a:stretch>
-            <a:fillRect/>
-          </a:stretch>
-        </p:blipFill>
-        <p:spPr>
-          <a:xfrm>
-            <a:off x="6546822" y="1792224"/>
-            <a:ext cx="1783643" cy="2368296"/>
-          </a:xfrm>
-          <a:prstGeom prst="rect">
-            <a:avLst/>
-          </a:prstGeom>
-        </p:spPr>
-      </p:pic>
+        <p:txBody>
+          <a:bodyPr/>
+          <a:lstStyle/>
+          <a:p>
+            <a:endParaRPr lang="en-US"/>
+          </a:p>
+        </p:txBody>
+      </p:sp>
+      <p:sp>
+        <p:nvSpPr>
+          <p:cNvPr id="14" name="Text 10">
+            <a:extLst>
+              <a:ext uri="{FF2B5EF4-FFF2-40B4-BE49-F238E27FC236}">
+                <a16:creationId xmlns:a16="http://schemas.microsoft.com/office/drawing/2014/main" id="{4DD636D4-DEE0-A671-43D4-11CC83EDAFE3}"/>
+              </a:ext>
+            </a:extLst>
+          </p:cNvPr>
+          <p:cNvSpPr/>
+          <p:nvPr/>
+        </p:nvSpPr>
+        <p:spPr>
+          <a:xfrm>
+            <a:off x="3008376" y="2882519"/>
+            <a:ext cx="5504688" cy="1424305"/>
+          </a:xfrm>
+          <a:prstGeom prst="rect">
+            <a:avLst/>
+          </a:prstGeom>
+          <a:noFill/>
+          <a:ln/>
+        </p:spPr>
+        <p:txBody>
+          <a:bodyPr wrap="square" rtlCol="0" anchor="t"/>
+          <a:lstStyle/>
+          <a:p>
+            <a:pPr marL="0" indent="0">
+              <a:spcAft>
+                <a:spcPts val="500"/>
+              </a:spcAft>
+              <a:buNone/>
+            </a:pPr>
+            <a:r>
+              <a:rPr lang="en-US" sz="1200" dirty="0">
+                <a:solidFill>
+                  <a:srgbClr val="1A1A1A"/>
+                </a:solidFill>
+                <a:latin typeface="Calibri" pitchFamily="34" charset="0"/>
+                <a:ea typeface="Calibri" pitchFamily="34" charset="-122"/>
+                <a:cs typeface="Calibri" pitchFamily="34" charset="-120"/>
+              </a:rPr>
+              <a:t>My Website</a:t>
+            </a:r>
+            <a:endParaRPr lang="en-US" sz="1200" dirty="0"/>
+          </a:p>
+          <a:p>
+            <a:pPr marL="0" indent="0">
+              <a:spcAft>
+                <a:spcPts val="800"/>
+              </a:spcAft>
+              <a:buNone/>
+            </a:pPr>
+            <a:r>
+              <a:rPr lang="en-US" sz="1200" dirty="0">
+                <a:solidFill>
+                  <a:srgbClr val="1A1A1A"/>
+                </a:solidFill>
+                <a:latin typeface="Calibri" pitchFamily="34" charset="0"/>
+                <a:ea typeface="Calibri" pitchFamily="34" charset="-122"/>
+                <a:cs typeface="Calibri" pitchFamily="34" charset="-120"/>
+              </a:rPr>
+              <a:t>Welcome to my personal site.</a:t>
+            </a:r>
+            <a:endParaRPr lang="en-US" sz="1200" dirty="0"/>
+          </a:p>
+          <a:p>
+            <a:pPr marL="0" indent="0">
+              <a:spcAft>
+                <a:spcPts val="300"/>
+              </a:spcAft>
+              <a:buNone/>
+            </a:pPr>
+            <a:r>
+              <a:rPr lang="en-US" sz="1200" dirty="0">
+                <a:solidFill>
+                  <a:srgbClr val="1A1A1A"/>
+                </a:solidFill>
+                <a:latin typeface="Calibri" pitchFamily="34" charset="0"/>
+                <a:ea typeface="Calibri" pitchFamily="34" charset="-122"/>
+                <a:cs typeface="Calibri" pitchFamily="34" charset="-120"/>
+              </a:rPr>
+              <a:t>About Me</a:t>
+            </a:r>
+            <a:endParaRPr lang="en-US" sz="1200" dirty="0"/>
+          </a:p>
+          <a:p>
+            <a:pPr marL="0" indent="0">
+              <a:spcAft>
+                <a:spcPts val="800"/>
+              </a:spcAft>
+              <a:buNone/>
+            </a:pPr>
+            <a:r>
+              <a:rPr lang="en-US" sz="1200" dirty="0">
+                <a:solidFill>
+                  <a:srgbClr val="1A1A1A"/>
+                </a:solidFill>
+                <a:latin typeface="Calibri" pitchFamily="34" charset="0"/>
+                <a:ea typeface="Calibri" pitchFamily="34" charset="-122"/>
+                <a:cs typeface="Calibri" pitchFamily="34" charset="-120"/>
+              </a:rPr>
+              <a:t>A short paragraph about who I am.</a:t>
+            </a:r>
+            <a:endParaRPr lang="en-US" sz="1200" dirty="0"/>
+          </a:p>
+          <a:p>
+            <a:pPr marL="0" indent="0">
+              <a:spcAft>
+                <a:spcPts val="300"/>
+              </a:spcAft>
+              <a:buNone/>
+            </a:pPr>
+            <a:r>
+              <a:rPr lang="en-US" sz="1200" dirty="0">
+                <a:solidFill>
+                  <a:srgbClr val="1A1A1A"/>
+                </a:solidFill>
+                <a:latin typeface="Calibri" pitchFamily="34" charset="0"/>
+                <a:ea typeface="Calibri" pitchFamily="34" charset="-122"/>
+                <a:cs typeface="Calibri" pitchFamily="34" charset="-120"/>
+              </a:rPr>
+              <a:t>My Hobbies</a:t>
+            </a:r>
+            <a:endParaRPr lang="en-US" sz="1200" dirty="0"/>
+          </a:p>
+          <a:p>
+            <a:pPr marL="0" indent="0">
+              <a:buNone/>
+            </a:pPr>
+            <a:r>
+              <a:rPr lang="en-US" sz="1200" dirty="0">
+                <a:solidFill>
+                  <a:srgbClr val="1A1A1A"/>
+                </a:solidFill>
+                <a:latin typeface="Calibri" pitchFamily="34" charset="0"/>
+                <a:ea typeface="Calibri" pitchFamily="34" charset="-122"/>
+                <a:cs typeface="Calibri" pitchFamily="34" charset="-120"/>
+              </a:rPr>
+              <a:t>A short paragraph about what I enjoy doing.</a:t>
+            </a:r>
+            <a:endParaRPr lang="en-US" sz="1200" dirty="0"/>
+          </a:p>
+        </p:txBody>
+      </p:sp>
     </p:spTree>
+    <p:extLst>
+      <p:ext uri="{BB962C8B-B14F-4D97-AF65-F5344CB8AC3E}">
+        <p14:creationId xmlns:p14="http://schemas.microsoft.com/office/powerpoint/2010/main" val="760785086"/>
+      </p:ext>
+    </p:extLst>
   </p:cSld>
   <p:clrMapOvr>
     <a:masterClrMapping/>
@@ -6319,4 +7362,319 @@
     </a:ext>
   </a:extLst>
 </a:theme>
+</file>
+
+<file path=ppt/theme/theme2.xml><?xml version="1.0" encoding="utf-8"?>
+<a:theme xmlns:a="http://schemas.openxmlformats.org/drawingml/2006/main" name="Office Theme">
+  <a:themeElements>
+    <a:clrScheme name="Office">
+      <a:dk1>
+        <a:sysClr val="windowText" lastClr="000000"/>
+      </a:dk1>
+      <a:lt1>
+        <a:sysClr val="window" lastClr="FFFFFF"/>
+      </a:lt1>
+      <a:dk2>
+        <a:srgbClr val="0E2841"/>
+      </a:dk2>
+      <a:lt2>
+        <a:srgbClr val="E8E8E8"/>
+      </a:lt2>
+      <a:accent1>
+        <a:srgbClr val="156082"/>
+      </a:accent1>
+      <a:accent2>
+        <a:srgbClr val="E97132"/>
+      </a:accent2>
+      <a:accent3>
+        <a:srgbClr val="196B24"/>
+      </a:accent3>
+      <a:accent4>
+        <a:srgbClr val="0F9ED5"/>
+      </a:accent4>
+      <a:accent5>
+        <a:srgbClr val="A02B93"/>
+      </a:accent5>
+      <a:accent6>
+        <a:srgbClr val="4EA72E"/>
+      </a:accent6>
+      <a:hlink>
+        <a:srgbClr val="467886"/>
+      </a:hlink>
+      <a:folHlink>
+        <a:srgbClr val="96607D"/>
+      </a:folHlink>
+    </a:clrScheme>
+    <a:fontScheme name="Office">
+      <a:majorFont>
+        <a:latin typeface="Aptos Display" panose="02110004020202020204"/>
+        <a:ea typeface=""/>
+        <a:cs typeface=""/>
+        <a:font script="Jpan" typeface="游ゴシック Light"/>
+        <a:font script="Hang" typeface="맑은 고딕"/>
+        <a:font script="Hans" typeface="等线 Light"/>
+        <a:font script="Hant" typeface="新細明體"/>
+        <a:font script="Arab" typeface="Times New Roman"/>
+        <a:font script="Hebr" typeface="Times New Roman"/>
+        <a:font script="Thai" typeface="Angsana New"/>
+        <a:font script="Ethi" typeface="Nyala"/>
+        <a:font script="Beng" typeface="Vrinda"/>
+        <a:font script="Gujr" typeface="Shruti"/>
+        <a:font script="Khmr" typeface="MoolBoran"/>
+        <a:font script="Knda" typeface="Tunga"/>
+        <a:font script="Guru" typeface="Raavi"/>
+        <a:font script="Cans" typeface="Euphemia"/>
+        <a:font script="Cher" typeface="Plantagenet Cherokee"/>
+        <a:font script="Yiii" typeface="Microsoft Yi Baiti"/>
+        <a:font script="Tibt" typeface="Microsoft Himalaya"/>
+        <a:font script="Thaa" typeface="MV Boli"/>
+        <a:font script="Deva" typeface="Mangal"/>
+        <a:font script="Telu" typeface="Gautami"/>
+        <a:font script="Taml" typeface="Latha"/>
+        <a:font script="Syrc" typeface="Estrangelo Edessa"/>
+        <a:font script="Orya" typeface="Kalinga"/>
+        <a:font script="Mlym" typeface="Kartika"/>
+        <a:font script="Laoo" typeface="DokChampa"/>
+        <a:font script="Sinh" typeface="Iskoola Pota"/>
+        <a:font script="Mong" typeface="Mongolian Baiti"/>
+        <a:font script="Viet" typeface="Times New Roman"/>
+        <a:font script="Uigh" typeface="Microsoft Uighur"/>
+        <a:font script="Geor" typeface="Sylfaen"/>
+        <a:font script="Armn" typeface="Arial"/>
+        <a:font script="Bugi" typeface="Leelawadee UI"/>
+        <a:font script="Bopo" typeface="Microsoft JhengHei"/>
+        <a:font script="Java" typeface="Javanese Text"/>
+        <a:font script="Lisu" typeface="Segoe UI"/>
+        <a:font script="Mymr" typeface="Myanmar Text"/>
+        <a:font script="Nkoo" typeface="Ebrima"/>
+        <a:font script="Olck" typeface="Nirmala UI"/>
+        <a:font script="Osma" typeface="Ebrima"/>
+        <a:font script="Phag" typeface="Phagspa"/>
+        <a:font script="Syrn" typeface="Estrangelo Edessa"/>
+        <a:font script="Syrj" typeface="Estrangelo Edessa"/>
+        <a:font script="Syre" typeface="Estrangelo Edessa"/>
+        <a:font script="Sora" typeface="Nirmala UI"/>
+        <a:font script="Tale" typeface="Microsoft Tai Le"/>
+        <a:font script="Talu" typeface="Microsoft New Tai Lue"/>
+        <a:font script="Tfng" typeface="Ebrima"/>
+      </a:majorFont>
+      <a:minorFont>
+        <a:latin typeface="Aptos" panose="02110004020202020204"/>
+        <a:ea typeface=""/>
+        <a:cs typeface=""/>
+        <a:font script="Jpan" typeface="游ゴシック"/>
+        <a:font script="Hang" typeface="맑은 고딕"/>
+        <a:font script="Hans" typeface="等线"/>
+        <a:font script="Hant" typeface="新細明體"/>
+        <a:font script="Arab" typeface="Arial"/>
+        <a:font script="Hebr" typeface="Arial"/>
+        <a:font script="Thai" typeface="Cordia New"/>
+        <a:font script="Ethi" typeface="Nyala"/>
+        <a:font script="Beng" typeface="Vrinda"/>
+        <a:font script="Gujr" typeface="Shruti"/>
+        <a:font script="Khmr" typeface="DaunPenh"/>
+        <a:font script="Knda" typeface="Tunga"/>
+        <a:font script="Guru" typeface="Raavi"/>
+        <a:font script="Cans" typeface="Euphemia"/>
+        <a:font script="Cher" typeface="Plantagenet Cherokee"/>
+        <a:font script="Yiii" typeface="Microsoft Yi Baiti"/>
+        <a:font script="Tibt" typeface="Microsoft Himalaya"/>
+        <a:font script="Thaa" typeface="MV Boli"/>
+        <a:font script="Deva" typeface="Mangal"/>
+        <a:font script="Telu" typeface="Gautami"/>
+        <a:font script="Taml" typeface="Latha"/>
+        <a:font script="Syrc" typeface="Estrangelo Edessa"/>
+        <a:font script="Orya" typeface="Kalinga"/>
+        <a:font script="Mlym" typeface="Kartika"/>
+        <a:font script="Laoo" typeface="DokChampa"/>
+        <a:font script="Sinh" typeface="Iskoola Pota"/>
+        <a:font script="Mong" typeface="Mongolian Baiti"/>
+        <a:font script="Viet" typeface="Arial"/>
+        <a:font script="Uigh" typeface="Microsoft Uighur"/>
+        <a:font script="Geor" typeface="Sylfaen"/>
+        <a:font script="Armn" typeface="Arial"/>
+        <a:font script="Bugi" typeface="Leelawadee UI"/>
+        <a:font script="Bopo" typeface="Microsoft JhengHei"/>
+        <a:font script="Java" typeface="Javanese Text"/>
+        <a:font script="Lisu" typeface="Segoe UI"/>
+        <a:font script="Mymr" typeface="Myanmar Text"/>
+        <a:font script="Nkoo" typeface="Ebrima"/>
+        <a:font script="Olck" typeface="Nirmala UI"/>
+        <a:font script="Osma" typeface="Ebrima"/>
+        <a:font script="Phag" typeface="Phagspa"/>
+        <a:font script="Syrn" typeface="Estrangelo Edessa"/>
+        <a:font script="Syrj" typeface="Estrangelo Edessa"/>
+        <a:font script="Syre" typeface="Estrangelo Edessa"/>
+        <a:font script="Sora" typeface="Nirmala UI"/>
+        <a:font script="Tale" typeface="Microsoft Tai Le"/>
+        <a:font script="Talu" typeface="Microsoft New Tai Lue"/>
+        <a:font script="Tfng" typeface="Ebrima"/>
+      </a:minorFont>
+    </a:fontScheme>
+    <a:fmtScheme name="Office">
+      <a:fillStyleLst>
+        <a:solidFill>
+          <a:schemeClr val="phClr"/>
+        </a:solidFill>
+        <a:gradFill rotWithShape="1">
+          <a:gsLst>
+            <a:gs pos="0">
+              <a:schemeClr val="phClr">
+                <a:lumMod val="110000"/>
+                <a:satMod val="105000"/>
+                <a:tint val="67000"/>
+              </a:schemeClr>
+            </a:gs>
+            <a:gs pos="50000">
+              <a:schemeClr val="phClr">
+                <a:lumMod val="105000"/>
+                <a:satMod val="103000"/>
+                <a:tint val="73000"/>
+              </a:schemeClr>
+            </a:gs>
+            <a:gs pos="100000">
+              <a:schemeClr val="phClr">
+                <a:lumMod val="105000"/>
+                <a:satMod val="109000"/>
+                <a:tint val="81000"/>
+              </a:schemeClr>
+            </a:gs>
+          </a:gsLst>
+          <a:lin ang="5400000" scaled="0"/>
+        </a:gradFill>
+        <a:gradFill rotWithShape="1">
+          <a:gsLst>
+            <a:gs pos="0">
+              <a:schemeClr val="phClr">
+                <a:satMod val="103000"/>
+                <a:lumMod val="102000"/>
+                <a:tint val="94000"/>
+              </a:schemeClr>
+            </a:gs>
+            <a:gs pos="50000">
+              <a:schemeClr val="phClr">
+                <a:satMod val="110000"/>
+                <a:lumMod val="100000"/>
+                <a:shade val="100000"/>
+              </a:schemeClr>
+            </a:gs>
+            <a:gs pos="100000">
+              <a:schemeClr val="phClr">
+                <a:lumMod val="99000"/>
+                <a:satMod val="120000"/>
+                <a:shade val="78000"/>
+              </a:schemeClr>
+            </a:gs>
+          </a:gsLst>
+          <a:lin ang="5400000" scaled="0"/>
+        </a:gradFill>
+      </a:fillStyleLst>
+      <a:lnStyleLst>
+        <a:ln w="12700" cap="flat" cmpd="sng" algn="ctr">
+          <a:solidFill>
+            <a:schemeClr val="phClr"/>
+          </a:solidFill>
+          <a:prstDash val="solid"/>
+          <a:miter lim="800000"/>
+        </a:ln>
+        <a:ln w="19050" cap="flat" cmpd="sng" algn="ctr">
+          <a:solidFill>
+            <a:schemeClr val="phClr"/>
+          </a:solidFill>
+          <a:prstDash val="solid"/>
+          <a:miter lim="800000"/>
+        </a:ln>
+        <a:ln w="25400" cap="flat" cmpd="sng" algn="ctr">
+          <a:solidFill>
+            <a:schemeClr val="phClr"/>
+          </a:solidFill>
+          <a:prstDash val="solid"/>
+          <a:miter lim="800000"/>
+        </a:ln>
+      </a:lnStyleLst>
+      <a:effectStyleLst>
+        <a:effectStyle>
+          <a:effectLst/>
+        </a:effectStyle>
+        <a:effectStyle>
+          <a:effectLst/>
+        </a:effectStyle>
+        <a:effectStyle>
+          <a:effectLst>
+            <a:outerShdw blurRad="57150" dist="19050" dir="5400000" algn="ctr" rotWithShape="0">
+              <a:srgbClr val="000000">
+                <a:alpha val="63000"/>
+              </a:srgbClr>
+            </a:outerShdw>
+          </a:effectLst>
+        </a:effectStyle>
+      </a:effectStyleLst>
+      <a:bgFillStyleLst>
+        <a:solidFill>
+          <a:schemeClr val="phClr"/>
+        </a:solidFill>
+        <a:solidFill>
+          <a:schemeClr val="phClr">
+            <a:tint val="95000"/>
+            <a:satMod val="170000"/>
+          </a:schemeClr>
+        </a:solidFill>
+        <a:gradFill rotWithShape="1">
+          <a:gsLst>
+            <a:gs pos="0">
+              <a:schemeClr val="phClr">
+                <a:tint val="93000"/>
+                <a:satMod val="150000"/>
+                <a:shade val="98000"/>
+                <a:lumMod val="102000"/>
+              </a:schemeClr>
+            </a:gs>
+            <a:gs pos="50000">
+              <a:schemeClr val="phClr">
+                <a:tint val="98000"/>
+                <a:satMod val="130000"/>
+                <a:shade val="90000"/>
+                <a:lumMod val="103000"/>
+              </a:schemeClr>
+            </a:gs>
+            <a:gs pos="100000">
+              <a:schemeClr val="phClr">
+                <a:shade val="63000"/>
+                <a:satMod val="120000"/>
+              </a:schemeClr>
+            </a:gs>
+          </a:gsLst>
+          <a:lin ang="5400000" scaled="0"/>
+        </a:gradFill>
+      </a:bgFillStyleLst>
+    </a:fmtScheme>
+  </a:themeElements>
+  <a:objectDefaults>
+    <a:lnDef>
+      <a:spPr/>
+      <a:bodyPr/>
+      <a:lstStyle/>
+      <a:style>
+        <a:lnRef idx="2">
+          <a:schemeClr val="accent1"/>
+        </a:lnRef>
+        <a:fillRef idx="0">
+          <a:schemeClr val="accent1"/>
+        </a:fillRef>
+        <a:effectRef idx="1">
+          <a:schemeClr val="accent1"/>
+        </a:effectRef>
+        <a:fontRef idx="minor">
+          <a:schemeClr val="tx1"/>
+        </a:fontRef>
+      </a:style>
+    </a:lnDef>
+  </a:objectDefaults>
+  <a:extraClrSchemeLst/>
+  <a:extLst>
+    <a:ext uri="{05A4C25C-085E-4340-85A3-A5531E510DB2}">
+      <thm15:themeFamily xmlns:thm15="http://schemas.microsoft.com/office/thememl/2012/main" name="Office Theme" id="{2E142A2C-CD16-42D6-873A-C26D2A0506FA}" vid="{1BDDFF52-6CD6-40A5-AB3C-68EB2F1E4D0A}"/>
+    </a:ext>
+  </a:extLst>
+</a:theme>
 </file>
</xml_diff>